<commit_message>
Updated the explanations of multiomics I, added answers to the questions, searched for mat2b and cys/methio metab
</commit_message>
<xml_diff>
--- a/slides/01_workshop_introduction.pptx
+++ b/slides/01_workshop_introduction.pptx
@@ -4052,7 +4052,7 @@
           <a:p>
             <a:fld id="{F6E21658-ACE2-2240-9971-015791891DE6}" type="datetimeFigureOut">
               <a:rPr lang="en-DK" smtClean="0"/>
-              <a:t>22/10/2026</a:t>
+              <a:t>24/10/2026</a:t>
             </a:fld>
             <a:endParaRPr lang="en-DK"/>
           </a:p>
@@ -16366,12 +16366,20 @@
               <a:buNone/>
             </a:pPr>
             <a:r>
+              <a:rPr lang="en-US" sz="1500">
+                <a:solidFill>
+                  <a:schemeClr val="tx2"/>
+                </a:solidFill>
+              </a:rPr>
+              <a:t>≤ 35 </a:t>
+            </a:r>
+            <a:r>
               <a:rPr lang="en-US" sz="1500" dirty="0">
                 <a:solidFill>
                   <a:schemeClr val="tx2"/>
                 </a:solidFill>
               </a:rPr>
-              <a:t>≤ 30 % missing</a:t>
+              <a:t>% missing</a:t>
             </a:r>
             <a:endParaRPr lang="en-US" sz="1500" dirty="0"/>
           </a:p>
@@ -18367,7 +18375,15 @@
                   <a:schemeClr val="tx2"/>
                 </a:solidFill>
               </a:rPr>
-              <a:t>Do SNF clusters match the groups — or a clinical lab?</a:t>
+              <a:t>Do SNF clusters match the groups — or the </a:t>
+            </a:r>
+            <a:r>
+              <a:rPr lang="en-US" sz="1500">
+                <a:solidFill>
+                  <a:schemeClr val="tx2"/>
+                </a:solidFill>
+              </a:rPr>
+              <a:t>clinical variables?</a:t>
             </a:r>
             <a:endParaRPr lang="en-US" sz="1500" dirty="0"/>
           </a:p>
@@ -19190,7 +19206,7 @@
         </p:nvSpPr>
         <p:spPr>
           <a:xfrm>
-            <a:off x="548640" y="320040"/>
+            <a:off x="548792" y="0"/>
             <a:ext cx="11094415" cy="777240"/>
           </a:xfrm>
           <a:prstGeom prst="rect">
@@ -19235,8 +19251,8 @@
         </p:nvSpPr>
         <p:spPr>
           <a:xfrm>
-            <a:off x="803564" y="1537855"/>
-            <a:ext cx="10487891" cy="2308324"/>
+            <a:off x="548792" y="708660"/>
+            <a:ext cx="11302889" cy="5909310"/>
           </a:xfrm>
           <a:prstGeom prst="rect">
             <a:avLst/>
@@ -19258,7 +19274,11 @@
           <a:p>
             <a:pPr lvl="0"/>
             <a:r>
-              <a:rPr lang="en-DK" dirty="0"/>
+              <a:rPr lang="en-DK" dirty="0">
+                <a:solidFill>
+                  <a:srgbClr val="FF0000"/>
+                </a:solidFill>
+              </a:rPr>
               <a:t>1. Is the Mantel correlation between the two layers positive? Is the signal shared or complementary?</a:t>
             </a:r>
           </a:p>
@@ -19269,8 +19289,23 @@
           <a:p>
             <a:pPr lvl="0"/>
             <a:r>
-              <a:rPr lang="en-DK" dirty="0"/>
-              <a:t>2. Do the SNF clusters match the clinical groups — or a clinical laboratory value?</a:t>
+              <a:rPr lang="en-DK" i="1" dirty="0"/>
+              <a:t>The correlation is slightly positive (rho=0.058), but almost zero and statistically non-significant (p = 0.491). This indicates that the global structures of the proteome and the metabolome in this cohort do not strongly mirror each other. Therefore, the signal is highly complementary rather than shared; each layer captures unique biological dimensions of the host response.</a:t>
+            </a:r>
+          </a:p>
+          <a:p>
+            <a:pPr lvl="0"/>
+            <a:endParaRPr lang="en-DK" i="1" dirty="0"/>
+          </a:p>
+          <a:p>
+            <a:pPr lvl="0"/>
+            <a:r>
+              <a:rPr lang="en-DK" dirty="0">
+                <a:solidFill>
+                  <a:srgbClr val="FF0000"/>
+                </a:solidFill>
+              </a:rPr>
+              <a:t>2. Do the SNF clusters match the pathogeneicity groups — or the clinical variables?</a:t>
             </a:r>
           </a:p>
           <a:p>
@@ -19278,10 +19313,13 @@
             <a:endParaRPr lang="en-DK" dirty="0"/>
           </a:p>
           <a:p>
-            <a:pPr lvl="0"/>
+            <a:r>
+              <a:rPr lang="en-GB" i="1" dirty="0"/>
+              <a:t>The clusters do not match the pathogen resistance groups (CSKP vs. CRKP). Instead, they match clinical variables representing the severity of the inflammatory host response. </a:t>
+            </a:r>
             <a:r>
               <a:rPr lang="en-DK" dirty="0"/>
-              <a:t>3. Which MOFA factor tracks group, and which tracks CRP, procalcitonin or creatinine?</a:t>
+              <a:t>Cluster 1 is characterized by a significantly higher systemic inflammatory profile, while cluster 0 and 2 contain mostly culture negative samples / less severe sepsis.</a:t>
             </a:r>
           </a:p>
           <a:p>
@@ -19289,7 +19327,38 @@
             <a:endParaRPr lang="en-DK" dirty="0"/>
           </a:p>
           <a:p>
+            <a:pPr lvl="0"/>
+            <a:r>
+              <a:rPr lang="en-DK" dirty="0">
+                <a:solidFill>
+                  <a:srgbClr val="FF0000"/>
+                </a:solidFill>
+              </a:rPr>
+              <a:t>3. Which MOFA factor tracks group, and which tracks CRP, procalcitonin or creatinine?</a:t>
+            </a:r>
+          </a:p>
+          <a:p>
+            <a:pPr lvl="0"/>
             <a:endParaRPr lang="en-DK" dirty="0"/>
+          </a:p>
+          <a:p>
+            <a:r>
+              <a:rPr lang="en-DK" i="1" dirty="0"/>
+              <a:t>Factor 2 is the most highly associated with clinical groups (Kruskal-Wallis p = 0.000022).</a:t>
+            </a:r>
+          </a:p>
+          <a:p>
+            <a:r>
+              <a:rPr lang="en-DK" i="1" dirty="0"/>
+              <a:t>Factor 1 has the strongest relationship with systemic inflammatory markers, showing a moderate Spearman correlation with Procalcitonin (rho = 0.452) and CRP (rho = 0.260)</a:t>
+            </a:r>
+            <a:br>
+              <a:rPr lang="en-DK" i="1" dirty="0"/>
+            </a:br>
+            <a:r>
+              <a:rPr lang="en-DK" i="1" dirty="0"/>
+              <a:t>Factor 4 has the strongest relationship with renal function exhibiting a moderate correlation with creatinine (rho = 0.483)</a:t>
+            </a:r>
           </a:p>
         </p:txBody>
       </p:sp>

</xml_diff>

<commit_message>
Updated contents and notes of 01_workshop_introduction.pptx
</commit_message>
<xml_diff>
--- a/slides/01_workshop_introduction.pptx
+++ b/slides/01_workshop_introduction.pptx
@@ -5,7 +5,7 @@
     <p:sldMasterId id="2147483648" r:id="rId1"/>
   </p:sldMasterIdLst>
   <p:notesMasterIdLst>
-    <p:notesMasterId r:id="rId33"/>
+    <p:notesMasterId r:id="rId32"/>
   </p:notesMasterIdLst>
   <p:sldIdLst>
     <p:sldId id="256" r:id="rId2"/>
@@ -32,13 +32,12 @@
     <p:sldId id="285" r:id="rId23"/>
     <p:sldId id="275" r:id="rId24"/>
     <p:sldId id="286" r:id="rId25"/>
-    <p:sldId id="287" r:id="rId26"/>
-    <p:sldId id="274" r:id="rId27"/>
-    <p:sldId id="288" r:id="rId28"/>
-    <p:sldId id="278" r:id="rId29"/>
-    <p:sldId id="279" r:id="rId30"/>
-    <p:sldId id="283" r:id="rId31"/>
-    <p:sldId id="290" r:id="rId32"/>
+    <p:sldId id="274" r:id="rId26"/>
+    <p:sldId id="288" r:id="rId27"/>
+    <p:sldId id="278" r:id="rId28"/>
+    <p:sldId id="279" r:id="rId29"/>
+    <p:sldId id="283" r:id="rId30"/>
+    <p:sldId id="290" r:id="rId31"/>
   </p:sldIdLst>
   <p:sldSz cx="12192000" cy="6858000"/>
   <p:notesSz cx="6858000" cy="12192000"/>
@@ -179,7 +178,6 @@
             <p14:sldId id="285"/>
             <p14:sldId id="275"/>
             <p14:sldId id="286"/>
-            <p14:sldId id="287"/>
             <p14:sldId id="274"/>
             <p14:sldId id="288"/>
           </p14:sldIdLst>
@@ -882,7 +880,16 @@
           <a:p>
             <a:r>
               <a:rPr lang="en-US" dirty="0"/>
-              <a:t>Welcome. In two hours we go from one real clinical cohort to a cross-omics hypothesis. About 20 minutes of context, then you work in the notebooks. Everything runs in Google Colab - no installation.</a:t>
+              <a:t>Welcome to the workshop. </a:t>
+            </a:r>
+          </a:p>
+          <a:p>
+            <a:endParaRPr lang="en-US" dirty="0"/>
+          </a:p>
+          <a:p>
+            <a:r>
+              <a:rPr lang="en-US" dirty="0"/>
+              <a:t>In two hours we go from one real clinical cohort to a cross-omics hypothesis. </a:t>
             </a:r>
           </a:p>
         </p:txBody>
@@ -1007,6 +1014,10 @@
               <a:defRPr/>
             </a:pPr>
             <a:r>
+              <a:rPr lang="en-US" dirty="0"/>
+              <a:t>For the proteomics data we use </a:t>
+            </a:r>
+            <a:r>
               <a:rPr lang="en-US" dirty="0" err="1"/>
               <a:t>quantmsdiann</a:t>
             </a:r>
@@ -1036,7 +1047,60 @@
             </a:r>
             <a:r>
               <a:rPr lang="en-US" dirty="0"/>
-              <a:t> at EMBL-EBI. The SDRF is generated by bin/</a:t>
+              <a:t> at EMBL-EBI. </a:t>
+            </a:r>
+          </a:p>
+          <a:p>
+            <a:pPr marL="0" marR="0" lvl="0" indent="0" algn="l" defTabSz="914400" rtl="0" eaLnBrk="1" fontAlgn="auto" latinLnBrk="0" hangingPunct="1">
+              <a:lnSpc>
+                <a:spcPct val="100000"/>
+              </a:lnSpc>
+              <a:spcBef>
+                <a:spcPts val="0"/>
+              </a:spcBef>
+              <a:spcAft>
+                <a:spcPts val="0"/>
+              </a:spcAft>
+              <a:buClrTx/>
+              <a:buSzTx/>
+              <a:buFontTx/>
+              <a:buNone/>
+              <a:tabLst/>
+              <a:defRPr/>
+            </a:pPr>
+            <a:endParaRPr lang="en-US" dirty="0"/>
+          </a:p>
+          <a:p>
+            <a:pPr marL="0" marR="0" lvl="0" indent="0" algn="l" defTabSz="914400" rtl="0" eaLnBrk="1" fontAlgn="auto" latinLnBrk="0" hangingPunct="1">
+              <a:lnSpc>
+                <a:spcPct val="100000"/>
+              </a:lnSpc>
+              <a:spcBef>
+                <a:spcPts val="0"/>
+              </a:spcBef>
+              <a:spcAft>
+                <a:spcPts val="0"/>
+              </a:spcAft>
+              <a:buClrTx/>
+              <a:buSzTx/>
+              <a:buFontTx/>
+              <a:buNone/>
+              <a:tabLst/>
+              <a:defRPr/>
+            </a:pPr>
+            <a:r>
+              <a:rPr lang="en-US" dirty="0"/>
+              <a:t>What the pipeline does.</a:t>
+            </a:r>
+            <a:br>
+              <a:rPr lang="en-US" dirty="0"/>
+            </a:br>
+            <a:br>
+              <a:rPr lang="en-US" dirty="0"/>
+            </a:br>
+            <a:r>
+              <a:rPr lang="en-US" dirty="0"/>
+              <a:t>The SDRF is generated by bin/</a:t>
             </a:r>
             <a:r>
               <a:rPr lang="en-US" dirty="0" err="1"/>
@@ -1092,7 +1156,21 @@
             <p:ph type="sldImg"/>
           </p:nvPr>
         </p:nvSpPr>
-        <p:spPr/>
+        <p:spPr>
+          <a:xfrm>
+            <a:off x="-228600" y="1524000"/>
+            <a:ext cx="7315200" cy="4114800"/>
+          </a:xfrm>
+          <a:prstGeom prst="rect">
+            <a:avLst/>
+          </a:prstGeom>
+          <a:noFill/>
+          <a:ln w="12700">
+            <a:solidFill>
+              <a:prstClr val="black"/>
+            </a:solidFill>
+          </a:ln>
+        </p:spPr>
       </p:sp>
       <p:sp>
         <p:nvSpPr>
@@ -1104,45 +1182,56 @@
             <p:ph type="body" idx="1"/>
           </p:nvPr>
         </p:nvSpPr>
-        <p:spPr/>
+        <p:spPr>
+          <a:xfrm>
+            <a:off x="685800" y="5867400"/>
+            <a:ext cx="5486400" cy="4800600"/>
+          </a:xfrm>
+          <a:prstGeom prst="rect">
+            <a:avLst/>
+          </a:prstGeom>
+        </p:spPr>
         <p:txBody>
           <a:bodyPr/>
           <a:lstStyle/>
           <a:p>
             <a:r>
-              <a:rPr lang="en-US" dirty="0"/>
-              <a:t>Good teaching moment: choose the pipeline that matches the acquisition. Untargeted and targeted metabolomics answer different questions. metaboigniter 2.0.1 also needs the legacy Nextflow config parser on Nextflow 26.04+.</a:t>
-            </a:r>
-          </a:p>
-        </p:txBody>
-      </p:sp>
-      <p:sp>
-        <p:nvSpPr>
-          <p:cNvPr id="4" name="Slide Number Placeholder 3"/>
-          <p:cNvSpPr>
-            <a:spLocks noGrp="1"/>
-          </p:cNvSpPr>
-          <p:nvPr>
-            <p:ph type="sldNum" sz="quarter" idx="10"/>
-          </p:nvPr>
-        </p:nvSpPr>
-        <p:spPr/>
-        <p:txBody>
-          <a:bodyPr/>
-          <a:lstStyle/>
-          <a:p>
-            <a:fld id="{F7021451-1387-4CA6-816F-3879F97B5CBC}" type="slidenum">
-              <a:rPr lang="en-US"/>
-              <a:t>12</a:t>
-            </a:fld>
-            <a:endParaRPr lang="en-US"/>
+              <a:rPr lang="en-DK" dirty="0"/>
+              <a:t>F</a:t>
+            </a:r>
+            <a:r>
+              <a:rPr lang="en-GB" dirty="0"/>
+              <a:t>o</a:t>
+            </a:r>
+            <a:r>
+              <a:rPr lang="en-DK" dirty="0"/>
+              <a:t>r metabolomics we are integrationg in our structure metaboigniter which is based on OpenMS tools</a:t>
+            </a:r>
+          </a:p>
+          <a:p>
+            <a:endParaRPr lang="en-DK" dirty="0"/>
+          </a:p>
+          <a:p>
+            <a:r>
+              <a:rPr lang="en-DK" dirty="0"/>
+              <a:t>What the pipeline does.</a:t>
+            </a:r>
+          </a:p>
+          <a:p>
+            <a:endParaRPr lang="en-DK" dirty="0"/>
+          </a:p>
+          <a:p>
+            <a:endParaRPr lang="en-DK" dirty="0"/>
+          </a:p>
+          <a:p>
+            <a:endParaRPr lang="en-DK" dirty="0"/>
           </a:p>
         </p:txBody>
       </p:sp>
     </p:spTree>
     <p:extLst>
       <p:ext uri="{BB962C8B-B14F-4D97-AF65-F5344CB8AC3E}">
-        <p14:creationId xmlns:p14="http://schemas.microsoft.com/office/powerpoint/2010/main" val="1024086991"/>
+        <p14:creationId xmlns:p14="http://schemas.microsoft.com/office/powerpoint/2010/main" val="3457171358"/>
       </p:ext>
     </p:extLst>
   </p:cSld>
@@ -1198,7 +1287,51 @@
           <a:p>
             <a:r>
               <a:rPr lang="en-US" dirty="0"/>
-              <a:t>The curated tables already harmonise identifiers. The run-order confound is not mentioned in the paper; keep it in mind when any result looks too good.</a:t>
+              <a:t>If you run the original course one day just keep in mind that </a:t>
+            </a:r>
+            <a:r>
+              <a:rPr lang="en-US" dirty="0" err="1"/>
+              <a:t>metaboigniter</a:t>
+            </a:r>
+            <a:r>
+              <a:rPr lang="en-US" dirty="0"/>
+              <a:t> is for untargeted </a:t>
+            </a:r>
+            <a:r>
+              <a:rPr lang="en-US" dirty="0" err="1"/>
+              <a:t>metabolics</a:t>
+            </a:r>
+            <a:r>
+              <a:rPr lang="en-US" dirty="0"/>
+              <a:t>, and in the paper they used targeted MRM metabolomics.</a:t>
+            </a:r>
+          </a:p>
+          <a:p>
+            <a:endParaRPr lang="en-US" dirty="0"/>
+          </a:p>
+          <a:p>
+            <a:r>
+              <a:rPr lang="en-US" dirty="0"/>
+              <a:t>Untargeted and targeted strategies have different acquisition methods and answer different questions. </a:t>
+            </a:r>
+            <a:br>
+              <a:rPr lang="en-US" dirty="0"/>
+            </a:br>
+            <a:br>
+              <a:rPr lang="en-US" dirty="0"/>
+            </a:br>
+            <a:r>
+              <a:rPr lang="en-US" dirty="0"/>
+              <a:t>So in the original course they used another untargeted dataset to show how to process the data</a:t>
+            </a:r>
+          </a:p>
+          <a:p>
+            <a:endParaRPr lang="en-US" dirty="0"/>
+          </a:p>
+          <a:p>
+            <a:r>
+              <a:rPr lang="en-US" dirty="0"/>
+              <a:t>Here today, in the repo you have the feature intensities already processed and ready for the multiomics integration</a:t>
             </a:r>
           </a:p>
         </p:txBody>
@@ -1220,7 +1353,7 @@
           <a:p>
             <a:fld id="{F7021451-1387-4CA6-816F-3879F97B5CBC}" type="slidenum">
               <a:rPr lang="en-US"/>
-              <a:t>13</a:t>
+              <a:t>12</a:t>
             </a:fld>
             <a:endParaRPr lang="en-US"/>
           </a:p>
@@ -1283,7 +1416,99 @@
           <a:bodyPr/>
           <a:lstStyle/>
           <a:p>
+            <a:r>
+              <a:rPr lang="en-US" dirty="0"/>
+              <a:t>With the use of public data we should be aware of few traps.</a:t>
+            </a:r>
+            <a:br>
+              <a:rPr lang="en-US" dirty="0"/>
+            </a:br>
+            <a:br>
+              <a:rPr lang="en-US" dirty="0"/>
+            </a:br>
+            <a:r>
+              <a:rPr lang="en-US" dirty="0"/>
+              <a:t>Sample names sometimes differ and they need to be </a:t>
+            </a:r>
+            <a:r>
+              <a:rPr lang="en-US" dirty="0" err="1"/>
+              <a:t>harmonise</a:t>
+            </a:r>
+            <a:r>
+              <a:rPr lang="en-US" dirty="0"/>
+              <a:t> before the analysis</a:t>
+            </a:r>
+          </a:p>
+          <a:p>
             <a:endParaRPr lang="en-US" dirty="0"/>
+          </a:p>
+          <a:p>
+            <a:r>
+              <a:rPr lang="en-US" dirty="0"/>
+              <a:t>Sometimes the metadata is broken or missing</a:t>
+            </a:r>
+            <a:br>
+              <a:rPr lang="en-US" dirty="0"/>
+            </a:br>
+            <a:endParaRPr lang="en-US" dirty="0"/>
+          </a:p>
+          <a:p>
+            <a:r>
+              <a:rPr lang="en-US" dirty="0"/>
+              <a:t>We need to </a:t>
+            </a:r>
+            <a:r>
+              <a:rPr lang="en-US" dirty="0" err="1"/>
+              <a:t>rememeber</a:t>
+            </a:r>
+            <a:r>
+              <a:rPr lang="en-US" dirty="0"/>
+              <a:t> to remove QC samples, they are not patients!</a:t>
+            </a:r>
+            <a:br>
+              <a:rPr lang="en-US" dirty="0"/>
+            </a:br>
+            <a:endParaRPr lang="en-US" dirty="0"/>
+          </a:p>
+          <a:p>
+            <a:r>
+              <a:rPr lang="en-US" dirty="0"/>
+              <a:t>We need to be aware that we should </a:t>
+            </a:r>
+            <a:r>
+              <a:rPr lang="en-US" sz="1200" i="1" dirty="0" err="1">
+                <a:solidFill>
+                  <a:schemeClr val="accent5"/>
+                </a:solidFill>
+              </a:rPr>
+              <a:t>randomise</a:t>
+            </a:r>
+            <a:r>
+              <a:rPr lang="en-US" sz="1200" i="1" dirty="0">
+                <a:solidFill>
+                  <a:schemeClr val="accent5"/>
+                </a:solidFill>
+              </a:rPr>
+              <a:t> or interleave injection order — and deposit these orders in the archives together with the samples</a:t>
+            </a:r>
+            <a:br>
+              <a:rPr lang="en-US" dirty="0"/>
+            </a:br>
+            <a:endParaRPr lang="en-US" dirty="0"/>
+          </a:p>
+          <a:p>
+            <a:r>
+              <a:rPr lang="en-US" sz="1200" dirty="0">
+                <a:solidFill>
+                  <a:schemeClr val="accent6"/>
+                </a:solidFill>
+              </a:rPr>
+              <a:t>In the paper, for Proteomics they injected the samples as in the same order as in the groups, therefore  instrument drift is inseparable from biology; no injection order was communicated for metabolomics.</a:t>
+            </a:r>
+            <a:r>
+              <a:rPr lang="en-US" dirty="0"/>
+              <a:t>; keep it in mind when any result looks too good.</a:t>
+            </a:r>
           </a:p>
         </p:txBody>
       </p:sp>
@@ -1304,7 +1529,7 @@
           <a:p>
             <a:fld id="{F7021451-1387-4CA6-816F-3879F97B5CBC}" type="slidenum">
               <a:rPr lang="en-US"/>
-              <a:t>14</a:t>
+              <a:t>13</a:t>
             </a:fld>
             <a:endParaRPr lang="en-US"/>
           </a:p>
@@ -1369,7 +1594,16 @@
           <a:p>
             <a:r>
               <a:rPr lang="en-US" dirty="0"/>
-              <a:t>Each step is a decision that changes the list. Imputation: in label-free proteomics a missing value usually means low abundance, so we draw from a down-shifted normal (shift 1.8 SD, width 0.25 SD, as in Perseus).</a:t>
+              <a:t>Let’s talk a bit about the paper findings for each data type</a:t>
+            </a:r>
+          </a:p>
+          <a:p>
+            <a:endParaRPr lang="en-US" dirty="0"/>
+          </a:p>
+          <a:p>
+            <a:r>
+              <a:rPr lang="en-US" dirty="0"/>
+              <a:t>Keep in mind that the most important contrast is susceptible vs resistant infection</a:t>
             </a:r>
           </a:p>
         </p:txBody>
@@ -1391,7 +1625,7 @@
           <a:p>
             <a:fld id="{F7021451-1387-4CA6-816F-3879F97B5CBC}" type="slidenum">
               <a:rPr lang="en-US"/>
-              <a:t>15</a:t>
+              <a:t>14</a:t>
             </a:fld>
             <a:endParaRPr lang="en-US"/>
           </a:p>
@@ -1456,8 +1690,53 @@
           <a:p>
             <a:r>
               <a:rPr lang="en-US" dirty="0"/>
-              <a:t>The viral-infection KEGG terms are generic: they contain the antigen-presentation genes. The panel AUC comes from a single split chosen on test performance, so read it as optimistic; the PRM validation cohort is the stronger evidence.</a:t>
-            </a:r>
+              <a:t>In data analysis each decision that you take influences the results.</a:t>
+            </a:r>
+          </a:p>
+          <a:p>
+            <a:endParaRPr lang="en-US" dirty="0"/>
+          </a:p>
+          <a:p>
+            <a:r>
+              <a:rPr lang="en-US" dirty="0"/>
+              <a:t>In Proteomics, they log2 transformed the data, filter proteins that were not in at least 70%, imputed from a </a:t>
+            </a:r>
+            <a:r>
+              <a:rPr lang="en-US" dirty="0" err="1"/>
+              <a:t>down+shifted</a:t>
+            </a:r>
+            <a:r>
+              <a:rPr lang="en-US" dirty="0"/>
+              <a:t> normal distribution, normalized by the median and tested the differences with ANOVA and </a:t>
+            </a:r>
+            <a:r>
+              <a:rPr lang="en-US" dirty="0" err="1"/>
+              <a:t>t+test</a:t>
+            </a:r>
+            <a:r>
+              <a:rPr lang="en-US" dirty="0"/>
+              <a:t> and performed an enrichment analysis using KEGG database.</a:t>
+            </a:r>
+          </a:p>
+          <a:p>
+            <a:endParaRPr lang="en-US" dirty="0"/>
+          </a:p>
+          <a:p>
+            <a:r>
+              <a:rPr lang="en-US" dirty="0"/>
+              <a:t>From 1458 proteins considered they found 85 differentially regulated proteins when comparing susceptible vs resistant with 51 proteins increasing ins stepwise con susceptible and resistant. They used a classifier to find a panel of four proteins that can predict the </a:t>
+            </a:r>
+            <a:r>
+              <a:rPr lang="en-US" dirty="0" err="1"/>
+              <a:t>pathogeneicity</a:t>
+            </a:r>
+            <a:r>
+              <a:rPr lang="en-US" dirty="0"/>
+              <a:t> group with an AUC 0.92 and validated in an external cohort.</a:t>
+            </a:r>
+          </a:p>
+          <a:p>
+            <a:endParaRPr lang="en-US" dirty="0"/>
           </a:p>
         </p:txBody>
       </p:sp>
@@ -1478,7 +1757,7 @@
           <a:p>
             <a:fld id="{F7021451-1387-4CA6-816F-3879F97B5CBC}" type="slidenum">
               <a:rPr lang="en-US"/>
-              <a:t>16</a:t>
+              <a:t>15</a:t>
             </a:fld>
             <a:endParaRPr lang="en-US"/>
           </a:p>
@@ -1543,8 +1822,65 @@
           <a:p>
             <a:r>
               <a:rPr lang="en-US" dirty="0"/>
-              <a:t>D-ratio = sigma_QC / sigma_biological; near 0 is biology, near 1 is measurement noise. QC CVs were low (median about 0.14) and samples ran in one batch, which reduces but does not remove the drift risk.</a:t>
-            </a:r>
+              <a:t>When they run enrichment analysis they found enriched </a:t>
+            </a:r>
+            <a:r>
+              <a:rPr lang="en-US" dirty="0" err="1"/>
+              <a:t>viral+infection</a:t>
+            </a:r>
+            <a:r>
+              <a:rPr lang="en-US" dirty="0"/>
+              <a:t> related pathways, </a:t>
+            </a:r>
+            <a:r>
+              <a:rPr lang="en-DK" dirty="0"/>
+              <a:t>antigen presentation, and phagosome function</a:t>
+            </a:r>
+            <a:endParaRPr lang="en-US" dirty="0"/>
+          </a:p>
+          <a:p>
+            <a:endParaRPr lang="en-US" dirty="0"/>
+          </a:p>
+          <a:p>
+            <a:endParaRPr lang="en-US" dirty="0"/>
+          </a:p>
+          <a:p>
+            <a:r>
+              <a:rPr lang="en-US" dirty="0"/>
+              <a:t>The panel AUC comes from a single split chosen on test performance, so read it as optimistic; the PRM validation cohort is the stronger evidence.</a:t>
+            </a:r>
+          </a:p>
+          <a:p>
+            <a:endParaRPr lang="en-US" dirty="0"/>
+          </a:p>
+          <a:p>
+            <a:endParaRPr lang="en-US" dirty="0"/>
+          </a:p>
+          <a:p>
+            <a:pPr marL="0" marR="0" lvl="0" indent="0" algn="l" defTabSz="914400" rtl="0" eaLnBrk="1" fontAlgn="auto" latinLnBrk="0" hangingPunct="1">
+              <a:lnSpc>
+                <a:spcPct val="100000"/>
+              </a:lnSpc>
+              <a:spcBef>
+                <a:spcPts val="0"/>
+              </a:spcBef>
+              <a:spcAft>
+                <a:spcPts val="0"/>
+              </a:spcAft>
+              <a:buClrTx/>
+              <a:buSzTx/>
+              <a:buFontTx/>
+              <a:buNone/>
+              <a:tabLst/>
+              <a:defRPr/>
+            </a:pPr>
+            <a:r>
+              <a:rPr lang="en-US" dirty="0"/>
+              <a:t>The viral-infection KEGG terms are generic: they contain the antigen-presentation genes. </a:t>
+            </a:r>
+          </a:p>
+          <a:p>
+            <a:endParaRPr lang="en-US" dirty="0"/>
           </a:p>
         </p:txBody>
       </p:sp>
@@ -1565,7 +1901,7 @@
           <a:p>
             <a:fld id="{F7021451-1387-4CA6-816F-3879F97B5CBC}" type="slidenum">
               <a:rPr lang="en-US"/>
-              <a:t>17</a:t>
+              <a:t>16</a:t>
             </a:fld>
             <a:endParaRPr lang="en-US"/>
           </a:p>
@@ -1630,7 +1966,104 @@
           <a:p>
             <a:r>
               <a:rPr lang="en-US" dirty="0"/>
-              <a:t>Bars are numbers of significant compounds per pathway from the paper's supplementary table 8. Pathway hits rest on few compounds; treat them as leads.</a:t>
+              <a:t>IN the metabolomics part again decisions that can affect the results</a:t>
+            </a:r>
+          </a:p>
+          <a:p>
+            <a:endParaRPr lang="en-US" dirty="0"/>
+          </a:p>
+          <a:p>
+            <a:pPr marL="0" marR="0" lvl="0" indent="0" algn="l" defTabSz="914400" rtl="0" eaLnBrk="1" fontAlgn="auto" latinLnBrk="0" hangingPunct="1">
+              <a:lnSpc>
+                <a:spcPct val="100000"/>
+              </a:lnSpc>
+              <a:spcBef>
+                <a:spcPts val="0"/>
+              </a:spcBef>
+              <a:spcAft>
+                <a:spcPts val="0"/>
+              </a:spcAft>
+              <a:buClrTx/>
+              <a:buSzTx/>
+              <a:buFontTx/>
+              <a:buNone/>
+              <a:tabLst/>
+              <a:defRPr/>
+            </a:pPr>
+            <a:r>
+              <a:rPr lang="en-US" sz="1200" dirty="0">
+                <a:solidFill>
+                  <a:schemeClr val="tx2"/>
+                </a:solidFill>
+              </a:rPr>
+              <a:t>They took metabolites measured in ≥ 80 % of patients</a:t>
+            </a:r>
+            <a:endParaRPr lang="en-US" sz="1200" dirty="0"/>
+          </a:p>
+          <a:p>
+            <a:endParaRPr lang="en-US" dirty="0"/>
+          </a:p>
+          <a:p>
+            <a:r>
+              <a:rPr lang="en-US" dirty="0"/>
+              <a:t>Different way of filtering the metabolites: CV of the qc samples had to be lower than the CV of patients </a:t>
+            </a:r>
+            <a:br>
+              <a:rPr lang="en-US" dirty="0"/>
+            </a:br>
+            <a:br>
+              <a:rPr lang="en-US" dirty="0"/>
+            </a:br>
+            <a:r>
+              <a:rPr lang="en-US" dirty="0"/>
+              <a:t>Technical biological dispersion  &lt; 0.5 </a:t>
+            </a:r>
+          </a:p>
+          <a:p>
+            <a:endParaRPr lang="en-US" dirty="0"/>
+          </a:p>
+          <a:p>
+            <a:r>
+              <a:rPr lang="en-US" dirty="0"/>
+              <a:t>They run an </a:t>
+            </a:r>
+            <a:r>
+              <a:rPr lang="en-US" dirty="0" err="1"/>
+              <a:t>ancova</a:t>
+            </a:r>
+            <a:r>
+              <a:rPr lang="en-US" dirty="0"/>
+              <a:t> to figure out the effect of the group but here they adjusted for age</a:t>
+            </a:r>
+          </a:p>
+          <a:p>
+            <a:endParaRPr lang="en-US" dirty="0"/>
+          </a:p>
+          <a:p>
+            <a:r>
+              <a:rPr lang="en-US" dirty="0"/>
+              <a:t>For enrichment they used KEGG also</a:t>
+            </a:r>
+          </a:p>
+          <a:p>
+            <a:endParaRPr lang="en-US" dirty="0"/>
+          </a:p>
+          <a:p>
+            <a:r>
+              <a:rPr lang="en-US" dirty="0"/>
+              <a:t>Here they considered 1073 metabolites and found 128 differentially regulated between susceptible and resistant group</a:t>
+            </a:r>
+          </a:p>
+          <a:p>
+            <a:endParaRPr lang="en-US" dirty="0"/>
+          </a:p>
+          <a:p>
+            <a:endParaRPr lang="en-US" dirty="0"/>
+          </a:p>
+          <a:p>
+            <a:r>
+              <a:rPr lang="en-US" dirty="0"/>
+              <a:t>D-ratio = sigma_QC / sigma_biological; near 0 is biology, near 1 is measurement noise. QC CVs were low (median about 0.14) and samples ran in one batch, which reduces but does not remove the drift risk.</a:t>
             </a:r>
           </a:p>
         </p:txBody>
@@ -1652,7 +2085,7 @@
           <a:p>
             <a:fld id="{F7021451-1387-4CA6-816F-3879F97B5CBC}" type="slidenum">
               <a:rPr lang="en-US"/>
-              <a:t>18</a:t>
+              <a:t>17</a:t>
             </a:fld>
             <a:endParaRPr lang="en-US"/>
           </a:p>
@@ -1715,9 +2148,65 @@
           <a:bodyPr/>
           <a:lstStyle/>
           <a:p>
+            <a:pPr marL="0" marR="0" lvl="0" indent="0" algn="l" defTabSz="914400" rtl="0" eaLnBrk="1" fontAlgn="auto" latinLnBrk="0" hangingPunct="1">
+              <a:lnSpc>
+                <a:spcPct val="100000"/>
+              </a:lnSpc>
+              <a:spcBef>
+                <a:spcPts val="0"/>
+              </a:spcBef>
+              <a:spcAft>
+                <a:spcPts val="0"/>
+              </a:spcAft>
+              <a:buClrTx/>
+              <a:buSzTx/>
+              <a:buFontTx/>
+              <a:buNone/>
+              <a:tabLst/>
+              <a:defRPr/>
+            </a:pPr>
             <a:r>
               <a:rPr lang="en-US" dirty="0"/>
-              <a:t>These two points set expectations for the hands-on: SNF and MOFA will probably not recover the three groups cleanly, and that is a result, not a failure.</a:t>
+              <a:t>When they did enrichment analysis they found thermogenesis and </a:t>
+            </a:r>
+            <a:r>
+              <a:rPr lang="en-US" dirty="0" err="1"/>
+              <a:t>aminoacid</a:t>
+            </a:r>
+            <a:r>
+              <a:rPr lang="en-US" dirty="0"/>
+              <a:t> and fatty acid degradation pathways enriched in resistant group</a:t>
+            </a:r>
+            <a:br>
+              <a:rPr lang="en-US" dirty="0"/>
+            </a:br>
+            <a:br>
+              <a:rPr lang="en-US" dirty="0"/>
+            </a:br>
+            <a:r>
+              <a:rPr lang="en-US" dirty="0"/>
+              <a:t>And the most interesting finding was about the methionine cycle. </a:t>
+            </a:r>
+            <a:r>
+              <a:rPr lang="en-US" sz="1200" dirty="0">
+                <a:solidFill>
+                  <a:schemeClr val="tx2"/>
+                </a:solidFill>
+              </a:rPr>
+              <a:t>Integrated pathway analysis of proteomic and metabolomic data highlighted dysregulation in cysteine/methionine metabolism and the folate-mediated one-carbon pool, with MAT2B as a key connecting protein. Keep that one in mind for later in our integration exercises.</a:t>
+            </a:r>
+            <a:r>
+              <a:rPr lang="en-US" dirty="0"/>
+              <a:t> </a:t>
+            </a:r>
+          </a:p>
+          <a:p>
+            <a:endParaRPr lang="en-US" dirty="0"/>
+          </a:p>
+          <a:p>
+            <a:r>
+              <a:rPr lang="en-US" dirty="0"/>
+              <a:t>Bars are numbers of significant compounds per pathway from the paper's supplementary table 8. Pathway hits rest on few compounds; treat them as leads.</a:t>
             </a:r>
           </a:p>
         </p:txBody>
@@ -1739,7 +2228,7 @@
           <a:p>
             <a:fld id="{F7021451-1387-4CA6-816F-3879F97B5CBC}" type="slidenum">
               <a:rPr lang="en-US"/>
-              <a:t>19</a:t>
+              <a:t>18</a:t>
             </a:fld>
             <a:endParaRPr lang="en-US"/>
           </a:p>
@@ -1802,6 +2291,70 @@
           <a:bodyPr/>
           <a:lstStyle/>
           <a:p>
+            <a:r>
+              <a:rPr lang="en-US" dirty="0"/>
+              <a:t>Two lessons before we integrate</a:t>
+            </a:r>
+          </a:p>
+          <a:p>
+            <a:endParaRPr lang="en-US" dirty="0"/>
+          </a:p>
+          <a:p>
+            <a:r>
+              <a:rPr lang="en-US" dirty="0"/>
+              <a:t>Sepsis severity dominates, the largest variance is about how ill a patient is, the resistance effect is probably a small perturbation in the top</a:t>
+            </a:r>
+          </a:p>
+          <a:p>
+            <a:endParaRPr lang="en-US" dirty="0"/>
+          </a:p>
+          <a:p>
+            <a:r>
+              <a:rPr lang="en-US" dirty="0"/>
+              <a:t>Also a results list of proteins and metabolites  is a product of the data plus our data analysis choices</a:t>
+            </a:r>
+          </a:p>
+          <a:p>
+            <a:endParaRPr lang="en-US" dirty="0"/>
+          </a:p>
+          <a:p>
+            <a:r>
+              <a:rPr lang="en-US" dirty="0"/>
+              <a:t>These two points set expectations for the hands-on: our methods will probably not recover the three groups cleanly, and that is a result, not a failure.</a:t>
+            </a:r>
+          </a:p>
+          <a:p>
+            <a:endParaRPr lang="en-US" dirty="0"/>
+          </a:p>
+          <a:p>
+            <a:pPr marL="0" marR="0" lvl="0" indent="0" algn="l" defTabSz="914400" rtl="0" eaLnBrk="1" fontAlgn="auto" latinLnBrk="0" hangingPunct="1">
+              <a:lnSpc>
+                <a:spcPct val="100000"/>
+              </a:lnSpc>
+              <a:spcBef>
+                <a:spcPts val="0"/>
+              </a:spcBef>
+              <a:spcAft>
+                <a:spcPts val="0"/>
+              </a:spcAft>
+              <a:buClrTx/>
+              <a:buSzTx/>
+              <a:buFontTx/>
+              <a:buNone/>
+              <a:tabLst/>
+              <a:defRPr/>
+            </a:pPr>
+            <a:r>
+              <a:rPr lang="en-US" sz="1200" i="1" dirty="0">
+                <a:solidFill>
+                  <a:schemeClr val="accent5"/>
+                </a:solidFill>
+              </a:rPr>
+              <a:t>So the question for integration is not 'do the groups separate?’ is more 'what structure is shared between layers, and where does a mechanism cross layers?'</a:t>
+            </a:r>
+            <a:endParaRPr lang="en-US" sz="1200" dirty="0"/>
+          </a:p>
+          <a:p>
             <a:endParaRPr lang="en-US" dirty="0"/>
           </a:p>
         </p:txBody>
@@ -1823,7 +2376,7 @@
           <a:p>
             <a:fld id="{F7021451-1387-4CA6-816F-3879F97B5CBC}" type="slidenum">
               <a:rPr lang="en-US"/>
-              <a:t>20</a:t>
+              <a:t>19</a:t>
             </a:fld>
             <a:endParaRPr lang="en-US"/>
           </a:p>
@@ -1888,7 +2441,52 @@
           <a:p>
             <a:r>
               <a:rPr lang="en-US" dirty="0"/>
-              <a:t>Timings are a guide. If Colab installs are slow, start Hands-on I while the lecture on multi-omics is shortened.</a:t>
+              <a:t>SO a plan for the next two hours:</a:t>
+            </a:r>
+          </a:p>
+          <a:p>
+            <a:endParaRPr lang="en-US" dirty="0"/>
+          </a:p>
+          <a:p>
+            <a:r>
+              <a:rPr lang="en-US" dirty="0"/>
+              <a:t> I will give you About 20/25 minutes of context, then you can work at your own pace in the notebooks. Notebooks run in Google </a:t>
+            </a:r>
+            <a:r>
+              <a:rPr lang="en-US" dirty="0" err="1"/>
+              <a:t>Colab</a:t>
+            </a:r>
+            <a:r>
+              <a:rPr lang="en-US" dirty="0"/>
+              <a:t> – no need of installations. </a:t>
+            </a:r>
+          </a:p>
+          <a:p>
+            <a:endParaRPr lang="en-US" dirty="0"/>
+          </a:p>
+          <a:p>
+            <a:r>
+              <a:rPr lang="en-US" dirty="0"/>
+              <a:t>You can also run it locally if you want to deal with the installations or already have the tools/libraries installed</a:t>
+            </a:r>
+            <a:br>
+              <a:rPr lang="en-US" dirty="0"/>
+            </a:br>
+            <a:br>
+              <a:rPr lang="en-US" dirty="0"/>
+            </a:br>
+            <a:r>
+              <a:rPr lang="en-US" dirty="0"/>
+              <a:t>Before each hands/on you can read in 10/15 min of theory from the slide decks.</a:t>
+            </a:r>
+          </a:p>
+          <a:p>
+            <a:endParaRPr lang="en-US" dirty="0"/>
+          </a:p>
+          <a:p>
+            <a:r>
+              <a:rPr lang="en-US" dirty="0"/>
+              <a:t>Timings are a guide. If Colab installs are slow, start Hands-on I while reading the material.</a:t>
             </a:r>
           </a:p>
         </p:txBody>
@@ -1930,6 +2528,99 @@
 </file>
 
 <file path=ppt/notesSlides/notesSlide20.xml><?xml version="1.0" encoding="utf-8"?>
+<p:notes xmlns:a="http://schemas.openxmlformats.org/drawingml/2006/main" xmlns:r="http://schemas.openxmlformats.org/officeDocument/2006/relationships" xmlns:p="http://schemas.openxmlformats.org/presentationml/2006/main">
+  <p:cSld>
+    <p:spTree>
+      <p:nvGrpSpPr>
+        <p:cNvPr id="1" name=""/>
+        <p:cNvGrpSpPr/>
+        <p:nvPr/>
+      </p:nvGrpSpPr>
+      <p:grpSpPr>
+        <a:xfrm>
+          <a:off x="0" y="0"/>
+          <a:ext cx="0" cy="0"/>
+          <a:chOff x="0" y="0"/>
+          <a:chExt cx="0" cy="0"/>
+        </a:xfrm>
+      </p:grpSpPr>
+      <p:sp>
+        <p:nvSpPr>
+          <p:cNvPr id="2" name="Slide Image Placeholder 1"/>
+          <p:cNvSpPr>
+            <a:spLocks noGrp="1" noRot="1" noChangeAspect="1"/>
+          </p:cNvSpPr>
+          <p:nvPr>
+            <p:ph type="sldImg"/>
+          </p:nvPr>
+        </p:nvSpPr>
+        <p:spPr/>
+      </p:sp>
+      <p:sp>
+        <p:nvSpPr>
+          <p:cNvPr id="3" name="Notes Placeholder 2"/>
+          <p:cNvSpPr>
+            <a:spLocks noGrp="1"/>
+          </p:cNvSpPr>
+          <p:nvPr>
+            <p:ph type="body" idx="1"/>
+          </p:nvPr>
+        </p:nvSpPr>
+        <p:spPr/>
+        <p:txBody>
+          <a:bodyPr/>
+          <a:lstStyle/>
+          <a:p>
+            <a:r>
+              <a:rPr lang="en-US" dirty="0"/>
+              <a:t>Finally few slides about integration and the methods you are going to see in the hands-on</a:t>
+            </a:r>
+          </a:p>
+          <a:p>
+            <a:endParaRPr lang="en-US" dirty="0"/>
+          </a:p>
+          <a:p>
+            <a:endParaRPr lang="en-US" dirty="0"/>
+          </a:p>
+        </p:txBody>
+      </p:sp>
+      <p:sp>
+        <p:nvSpPr>
+          <p:cNvPr id="4" name="Slide Number Placeholder 3"/>
+          <p:cNvSpPr>
+            <a:spLocks noGrp="1"/>
+          </p:cNvSpPr>
+          <p:nvPr>
+            <p:ph type="sldNum" sz="quarter" idx="10"/>
+          </p:nvPr>
+        </p:nvSpPr>
+        <p:spPr/>
+        <p:txBody>
+          <a:bodyPr/>
+          <a:lstStyle/>
+          <a:p>
+            <a:fld id="{F7021451-1387-4CA6-816F-3879F97B5CBC}" type="slidenum">
+              <a:rPr lang="en-US"/>
+              <a:t>20</a:t>
+            </a:fld>
+            <a:endParaRPr lang="en-US"/>
+          </a:p>
+        </p:txBody>
+      </p:sp>
+    </p:spTree>
+    <p:extLst>
+      <p:ext uri="{BB962C8B-B14F-4D97-AF65-F5344CB8AC3E}">
+        <p14:creationId xmlns:p14="http://schemas.microsoft.com/office/powerpoint/2010/main" val="1024086991"/>
+      </p:ext>
+    </p:extLst>
+  </p:cSld>
+  <p:clrMapOvr>
+    <a:masterClrMapping/>
+  </p:clrMapOvr>
+</p:notes>
+</file>
+
+<file path=ppt/notesSlides/notesSlide21.xml><?xml version="1.0" encoding="utf-8"?>
 <p:notes xmlns:a="http://schemas.openxmlformats.org/drawingml/2006/main" xmlns:r="http://schemas.openxmlformats.org/officeDocument/2006/relationships" xmlns:p="http://schemas.openxmlformats.org/presentationml/2006/main" showMasterSp="0" showMasterPhAnim="0">
   <p:cSld>
     <p:spTree>
@@ -1958,7 +2649,7 @@
         </p:nvSpPr>
         <p:spPr>
           <a:xfrm>
-            <a:off x="381300" y="685800"/>
+            <a:off x="381000" y="685800"/>
             <a:ext cx="6096000" cy="3429000"/>
           </a:xfrm>
           <a:custGeom>
@@ -2021,7 +2712,100 @@
               </a:spcAft>
               <a:buNone/>
             </a:pPr>
-            <a:endParaRPr/>
+            <a:r>
+              <a:rPr lang="en-US" dirty="0"/>
+              <a:t>First of all why is multiomics integration key?</a:t>
+            </a:r>
+          </a:p>
+          <a:p>
+            <a:pPr marL="0" lvl="0" indent="0" algn="l" rtl="0">
+              <a:spcBef>
+                <a:spcPts val="0"/>
+              </a:spcBef>
+              <a:spcAft>
+                <a:spcPts val="0"/>
+              </a:spcAft>
+              <a:buNone/>
+            </a:pPr>
+            <a:endParaRPr lang="en-US" dirty="0"/>
+          </a:p>
+          <a:p>
+            <a:pPr marL="0" lvl="0" indent="0" algn="l" rtl="0">
+              <a:spcBef>
+                <a:spcPts val="0"/>
+              </a:spcBef>
+              <a:spcAft>
+                <a:spcPts val="0"/>
+              </a:spcAft>
+              <a:buNone/>
+            </a:pPr>
+            <a:r>
+              <a:rPr lang="en-US" dirty="0"/>
+              <a:t>Discover mechanisms that were hidden on single omics analysis</a:t>
+            </a:r>
+          </a:p>
+          <a:p>
+            <a:pPr marL="0" lvl="0" indent="0" algn="l" rtl="0">
+              <a:spcBef>
+                <a:spcPts val="0"/>
+              </a:spcBef>
+              <a:spcAft>
+                <a:spcPts val="0"/>
+              </a:spcAft>
+              <a:buNone/>
+            </a:pPr>
+            <a:endParaRPr lang="en-US" dirty="0"/>
+          </a:p>
+          <a:p>
+            <a:pPr marL="0" lvl="0" indent="0" algn="l" rtl="0">
+              <a:spcBef>
+                <a:spcPts val="0"/>
+              </a:spcBef>
+              <a:spcAft>
+                <a:spcPts val="0"/>
+              </a:spcAft>
+              <a:buNone/>
+            </a:pPr>
+            <a:r>
+              <a:rPr lang="en-US" dirty="0"/>
+              <a:t>Refine phenotypic subtypes: for example disease severity, disease stages, inflammation profiles….besides our study groups</a:t>
+            </a:r>
+          </a:p>
+          <a:p>
+            <a:pPr marL="0" lvl="0" indent="0" algn="l" rtl="0">
+              <a:spcBef>
+                <a:spcPts val="0"/>
+              </a:spcBef>
+              <a:spcAft>
+                <a:spcPts val="0"/>
+              </a:spcAft>
+              <a:buNone/>
+            </a:pPr>
+            <a:endParaRPr lang="en-US" dirty="0"/>
+          </a:p>
+          <a:p>
+            <a:pPr marL="0" lvl="0" indent="0" algn="l" rtl="0">
+              <a:spcBef>
+                <a:spcPts val="0"/>
+              </a:spcBef>
+              <a:spcAft>
+                <a:spcPts val="0"/>
+              </a:spcAft>
+              <a:buNone/>
+            </a:pPr>
+            <a:r>
+              <a:rPr lang="en-US" dirty="0"/>
+              <a:t>Find better biomarkers  for across layers mechanisms that improve disease diagnosis, prognosis, </a:t>
+            </a:r>
+            <a:r>
+              <a:rPr lang="en-US" dirty="0" err="1"/>
+              <a:t>etc</a:t>
+            </a:r>
+            <a:r>
+              <a:rPr lang="en-US" dirty="0"/>
+              <a:t>…</a:t>
+            </a:r>
+            <a:endParaRPr dirty="0"/>
           </a:p>
         </p:txBody>
       </p:sp>
@@ -2033,7 +2817,7 @@
 </p:notes>
 </file>
 
-<file path=ppt/notesSlides/notesSlide21.xml><?xml version="1.0" encoding="utf-8"?>
+<file path=ppt/notesSlides/notesSlide22.xml><?xml version="1.0" encoding="utf-8"?>
 <p:notes xmlns:a="http://schemas.openxmlformats.org/drawingml/2006/main" xmlns:r="http://schemas.openxmlformats.org/officeDocument/2006/relationships" xmlns:p="http://schemas.openxmlformats.org/presentationml/2006/main" showMasterSp="0" showMasterPhAnim="0">
   <p:cSld>
     <p:spTree>
@@ -2084,7 +2868,80 @@
               </a:spcAft>
               <a:buNone/>
             </a:pPr>
-            <a:endParaRPr/>
+            <a:r>
+              <a:rPr lang="en-US" dirty="0"/>
+              <a:t>There are two types of data integration:</a:t>
+            </a:r>
+          </a:p>
+          <a:p>
+            <a:pPr marL="0" lvl="0" indent="0" algn="l" rtl="0">
+              <a:spcBef>
+                <a:spcPts val="0"/>
+              </a:spcBef>
+              <a:spcAft>
+                <a:spcPts val="0"/>
+              </a:spcAft>
+              <a:buNone/>
+            </a:pPr>
+            <a:endParaRPr lang="en-US" dirty="0"/>
+          </a:p>
+          <a:p>
+            <a:pPr marL="0" lvl="0" indent="0" algn="l" rtl="0">
+              <a:spcBef>
+                <a:spcPts val="0"/>
+              </a:spcBef>
+              <a:spcAft>
+                <a:spcPts val="0"/>
+              </a:spcAft>
+              <a:buNone/>
+            </a:pPr>
+            <a:r>
+              <a:rPr lang="en-US" dirty="0"/>
+              <a:t>1 horizontal where we integrate different studies of the same omics</a:t>
+            </a:r>
+          </a:p>
+          <a:p>
+            <a:pPr marL="0" lvl="0" indent="0" algn="l" rtl="0">
+              <a:spcBef>
+                <a:spcPts val="0"/>
+              </a:spcBef>
+              <a:spcAft>
+                <a:spcPts val="0"/>
+              </a:spcAft>
+              <a:buNone/>
+            </a:pPr>
+            <a:r>
+              <a:rPr lang="en-US" dirty="0"/>
+              <a:t>2 vertical where we integrate different omics on the same study (what we have in out integration of today’s workshop)</a:t>
+            </a:r>
+          </a:p>
+          <a:p>
+            <a:pPr marL="0" lvl="0" indent="0" algn="l" rtl="0">
+              <a:spcBef>
+                <a:spcPts val="0"/>
+              </a:spcBef>
+              <a:spcAft>
+                <a:spcPts val="0"/>
+              </a:spcAft>
+              <a:buNone/>
+            </a:pPr>
+            <a:endParaRPr lang="en-US" dirty="0"/>
+          </a:p>
+          <a:p>
+            <a:pPr marL="0" lvl="0" indent="0" algn="l" rtl="0">
+              <a:spcBef>
+                <a:spcPts val="0"/>
+              </a:spcBef>
+              <a:spcAft>
+                <a:spcPts val="0"/>
+              </a:spcAft>
+              <a:buNone/>
+            </a:pPr>
+            <a:r>
+              <a:rPr lang="en-US" dirty="0"/>
+              <a:t>Both types are tackled with different methods and approaches.</a:t>
+            </a:r>
+            <a:endParaRPr dirty="0"/>
           </a:p>
         </p:txBody>
       </p:sp>
@@ -2100,8 +2957,8 @@
         </p:nvSpPr>
         <p:spPr>
           <a:xfrm>
-            <a:off x="1143000" y="685800"/>
-            <a:ext cx="4572000" cy="3429000"/>
+            <a:off x="381000" y="685800"/>
+            <a:ext cx="6096000" cy="3429000"/>
           </a:xfrm>
           <a:custGeom>
             <a:avLst/>
@@ -2137,7 +2994,7 @@
 </p:notes>
 </file>
 
-<file path=ppt/notesSlides/notesSlide22.xml><?xml version="1.0" encoding="utf-8"?>
+<file path=ppt/notesSlides/notesSlide23.xml><?xml version="1.0" encoding="utf-8"?>
 <p:notes xmlns:a="http://schemas.openxmlformats.org/drawingml/2006/main" xmlns:r="http://schemas.openxmlformats.org/officeDocument/2006/relationships" xmlns:p="http://schemas.openxmlformats.org/presentationml/2006/main">
   <p:cSld>
     <p:spTree>
@@ -2181,10 +3038,104 @@
           <a:bodyPr/>
           <a:lstStyle/>
           <a:p>
+            <a:endParaRPr lang="en-US" dirty="0"/>
+          </a:p>
+          <a:p>
             <a:r>
               <a:rPr lang="en-US" dirty="0"/>
-              <a:t>This is the unglamorous step where most integration attempts fail. The same recipe is applied symmetrically to both layers.</a:t>
-            </a:r>
+              <a:t>Before integration there is a step 0 very important!</a:t>
+            </a:r>
+          </a:p>
+          <a:p>
+            <a:endParaRPr lang="en-US" dirty="0"/>
+          </a:p>
+          <a:p>
+            <a:r>
+              <a:rPr lang="en-US" dirty="0"/>
+              <a:t>We have </a:t>
+            </a:r>
+            <a:r>
+              <a:rPr lang="en-US" sz="1200" b="1" dirty="0">
+                <a:solidFill>
+                  <a:schemeClr val="tx1"/>
+                </a:solidFill>
+                <a:latin typeface="Cambria" pitchFamily="34" charset="0"/>
+                <a:ea typeface="Cambria" pitchFamily="34" charset="-122"/>
+                <a:cs typeface="Cambria" pitchFamily="34" charset="-120"/>
+              </a:rPr>
+              <a:t>two physiology views of the same patients</a:t>
+            </a:r>
+          </a:p>
+          <a:p>
+            <a:endParaRPr lang="en-US" sz="1200" b="1" dirty="0">
+              <a:solidFill>
+                <a:schemeClr val="tx1"/>
+              </a:solidFill>
+              <a:latin typeface="Cambria" pitchFamily="34" charset="0"/>
+            </a:endParaRPr>
+          </a:p>
+          <a:p>
+            <a:r>
+              <a:rPr lang="en-US" dirty="0"/>
+              <a:t>The same recipe needs to be applied symmetrically to both layers for them to be comparable</a:t>
+            </a:r>
+          </a:p>
+          <a:p>
+            <a:endParaRPr lang="en-US" dirty="0"/>
+          </a:p>
+          <a:p>
+            <a:r>
+              <a:rPr lang="en-US" dirty="0"/>
+              <a:t>In both layers we are going to check that the IDs are the same – silent sample mismatches is a common cause of producing no sense results</a:t>
+            </a:r>
+          </a:p>
+          <a:p>
+            <a:endParaRPr lang="en-US" dirty="0"/>
+          </a:p>
+          <a:p>
+            <a:r>
+              <a:rPr lang="en-US" dirty="0"/>
+              <a:t>log2 transform the data so that we can observe changes among high and among low abundant features</a:t>
+            </a:r>
+          </a:p>
+          <a:p>
+            <a:endParaRPr lang="en-US" dirty="0"/>
+          </a:p>
+          <a:p>
+            <a:r>
+              <a:rPr lang="en-US" dirty="0"/>
+              <a:t>we are going to filter out low prevalent features</a:t>
+            </a:r>
+          </a:p>
+          <a:p>
+            <a:endParaRPr lang="en-US" dirty="0"/>
+          </a:p>
+          <a:p>
+            <a:r>
+              <a:rPr lang="en-US" dirty="0"/>
+              <a:t>and impute data with the lowest value for each feature – usually in label free MS studies they consider that inf a value is not observed it is because it is low below limit of detection</a:t>
+            </a:r>
+          </a:p>
+          <a:p>
+            <a:endParaRPr lang="en-US" dirty="0"/>
+          </a:p>
+          <a:p>
+            <a:r>
+              <a:rPr lang="en-US" dirty="0"/>
+              <a:t>and finally we z-score per feature and </a:t>
+            </a:r>
+            <a:r>
+              <a:rPr lang="en-US" sz="1200" dirty="0">
+                <a:solidFill>
+                  <a:schemeClr val="tx2"/>
+                </a:solidFill>
+              </a:rPr>
+              <a:t>that stops one feature dominating by units and one layer dominating by dynamic range</a:t>
+            </a:r>
+            <a:endParaRPr lang="en-US" dirty="0"/>
+          </a:p>
+          <a:p>
+            <a:endParaRPr lang="en-US" dirty="0"/>
           </a:p>
         </p:txBody>
       </p:sp>
@@ -2224,7 +3175,7 @@
 </p:notes>
 </file>
 
-<file path=ppt/notesSlides/notesSlide23.xml><?xml version="1.0" encoding="utf-8"?>
+<file path=ppt/notesSlides/notesSlide24.xml><?xml version="1.0" encoding="utf-8"?>
 <p:notes xmlns:a="http://schemas.openxmlformats.org/drawingml/2006/main" xmlns:r="http://schemas.openxmlformats.org/officeDocument/2006/relationships" xmlns:p="http://schemas.openxmlformats.org/presentationml/2006/main" showMasterSp="0" showMasterPhAnim="0">
   <p:cSld>
     <p:spTree>
@@ -2316,100 +3267,11 @@
               </a:spcAft>
               <a:buNone/>
             </a:pPr>
-            <a:endParaRPr/>
-          </a:p>
-        </p:txBody>
-      </p:sp>
-    </p:spTree>
-  </p:cSld>
-  <p:clrMapOvr>
-    <a:masterClrMapping/>
-  </p:clrMapOvr>
-</p:notes>
-</file>
-
-<file path=ppt/notesSlides/notesSlide24.xml><?xml version="1.0" encoding="utf-8"?>
-<p:notes xmlns:a="http://schemas.openxmlformats.org/drawingml/2006/main" xmlns:r="http://schemas.openxmlformats.org/officeDocument/2006/relationships" xmlns:p="http://schemas.openxmlformats.org/presentationml/2006/main" showMasterSp="0" showMasterPhAnim="0">
-  <p:cSld>
-    <p:spTree>
-      <p:nvGrpSpPr>
-        <p:cNvPr id="1" name="Shape 266"/>
-        <p:cNvGrpSpPr/>
-        <p:nvPr/>
-      </p:nvGrpSpPr>
-      <p:grpSpPr>
-        <a:xfrm>
-          <a:off x="0" y="0"/>
-          <a:ext cx="0" cy="0"/>
-          <a:chOff x="0" y="0"/>
-          <a:chExt cx="0" cy="0"/>
-        </a:xfrm>
-      </p:grpSpPr>
-      <p:sp>
-        <p:nvSpPr>
-          <p:cNvPr id="267" name="Google Shape;267;g390d080a095_1_338:notes"/>
-          <p:cNvSpPr>
-            <a:spLocks noGrp="1" noRot="1" noChangeAspect="1"/>
-          </p:cNvSpPr>
-          <p:nvPr>
-            <p:ph type="sldImg" idx="2"/>
-          </p:nvPr>
-        </p:nvSpPr>
-        <p:spPr>
-          <a:xfrm>
-            <a:off x="381000" y="685800"/>
-            <a:ext cx="6096000" cy="3429000"/>
-          </a:xfrm>
-          <a:custGeom>
-            <a:avLst/>
-            <a:gdLst/>
-            <a:ahLst/>
-            <a:cxnLst/>
-            <a:rect l="l" t="t" r="r" b="b"/>
-            <a:pathLst>
-              <a:path w="120000" h="120000" extrusionOk="0">
-                <a:moveTo>
-                  <a:pt x="0" y="0"/>
-                </a:moveTo>
-                <a:lnTo>
-                  <a:pt x="120000" y="0"/>
-                </a:lnTo>
-                <a:lnTo>
-                  <a:pt x="120000" y="120000"/>
-                </a:lnTo>
-                <a:lnTo>
-                  <a:pt x="0" y="120000"/>
-                </a:lnTo>
-                <a:close/>
-              </a:path>
-            </a:pathLst>
-          </a:custGeom>
-        </p:spPr>
-      </p:sp>
-      <p:sp>
-        <p:nvSpPr>
-          <p:cNvPr id="268" name="Google Shape;268;g390d080a095_1_338:notes"/>
-          <p:cNvSpPr txBox="1">
-            <a:spLocks noGrp="1"/>
-          </p:cNvSpPr>
-          <p:nvPr>
-            <p:ph type="body" idx="1"/>
-          </p:nvPr>
-        </p:nvSpPr>
-        <p:spPr>
-          <a:xfrm>
-            <a:off x="685800" y="4343400"/>
-            <a:ext cx="5486400" cy="4114800"/>
-          </a:xfrm>
-          <a:prstGeom prst="rect">
-            <a:avLst/>
-          </a:prstGeom>
-        </p:spPr>
-        <p:txBody>
-          <a:bodyPr spcFirstLastPara="1" wrap="square" lIns="91425" tIns="91425" rIns="91425" bIns="91425" anchor="t" anchorCtr="0">
-            <a:noAutofit/>
-          </a:bodyPr>
-          <a:lstStyle/>
+            <a:r>
+              <a:rPr lang="en-US" dirty="0"/>
+              <a:t>First method that you will see is Similarity network fusion</a:t>
+            </a:r>
+          </a:p>
           <a:p>
             <a:pPr marL="0" lvl="0" indent="0" algn="l" rtl="0">
               <a:spcBef>
@@ -2420,7 +3282,19 @@
               </a:spcAft>
               <a:buNone/>
             </a:pPr>
-            <a:endParaRPr/>
+            <a:endParaRPr lang="en-US" dirty="0"/>
+          </a:p>
+          <a:p>
+            <a:pPr marL="0" lvl="0" indent="0" algn="l" rtl="0">
+              <a:spcBef>
+                <a:spcPts val="0"/>
+              </a:spcBef>
+              <a:spcAft>
+                <a:spcPts val="0"/>
+              </a:spcAft>
+              <a:buNone/>
+            </a:pPr>
+            <a:endParaRPr dirty="0"/>
           </a:p>
         </p:txBody>
       </p:sp>
@@ -2524,7 +3398,11 @@
               </a:spcAft>
               <a:buNone/>
             </a:pPr>
-            <a:endParaRPr/>
+            <a:r>
+              <a:rPr lang="en-US" dirty="0"/>
+              <a:t>Example of the switches turning on/off features</a:t>
+            </a:r>
+            <a:endParaRPr dirty="0"/>
           </a:p>
         </p:txBody>
       </p:sp>
@@ -2686,7 +3564,73 @@
           <a:p>
             <a:r>
               <a:rPr lang="en-US" dirty="0"/>
-              <a:t>Both notebooks are self-contained: they download the curated tables from the workshop repository on GitHub and need no output from earlier sessions. Ask people to start the install cell immediately. Cytoscape export is optional; skip it if Cytoscape is not installed.</a:t>
+              <a:t>Ok so now it is your turn to get hands on data integration.</a:t>
+            </a:r>
+          </a:p>
+          <a:p>
+            <a:endParaRPr lang="en-US" dirty="0"/>
+          </a:p>
+          <a:p>
+            <a:r>
+              <a:rPr lang="en-US" dirty="0"/>
+              <a:t>As I said there are two slide decks to read before the hands-on if you want, otherwise you jump directly to the hands on notebook in google </a:t>
+            </a:r>
+            <a:r>
+              <a:rPr lang="en-US" dirty="0" err="1"/>
+              <a:t>colab</a:t>
+            </a:r>
+            <a:r>
+              <a:rPr lang="en-US" dirty="0"/>
+              <a:t>. </a:t>
+            </a:r>
+          </a:p>
+          <a:p>
+            <a:endParaRPr lang="en-US" dirty="0"/>
+          </a:p>
+          <a:p>
+            <a:r>
+              <a:rPr lang="en-US" dirty="0"/>
+              <a:t>Both notebooks are self-contained: they download the curated tables from the workshop repository on GitHub and need no output from earlier sessions.</a:t>
+            </a:r>
+          </a:p>
+          <a:p>
+            <a:endParaRPr lang="en-US" dirty="0"/>
+          </a:p>
+          <a:p>
+            <a:r>
+              <a:rPr lang="en-US" dirty="0" err="1"/>
+              <a:t>Cytoscape</a:t>
+            </a:r>
+            <a:r>
+              <a:rPr lang="en-US" dirty="0"/>
+              <a:t> export is optional; skip it if Cytoscape is not installed.</a:t>
+            </a:r>
+            <a:br>
+              <a:rPr lang="en-US" dirty="0"/>
+            </a:br>
+            <a:endParaRPr lang="en-US" dirty="0"/>
+          </a:p>
+          <a:p>
+            <a:r>
+              <a:rPr lang="en-US" dirty="0"/>
+              <a:t>Focus on having a general idea of what we do instead of getting stuck on each single detail. The material is open and you can get back to it later whenever you want to consolidate your understanding.</a:t>
+            </a:r>
+          </a:p>
+          <a:p>
+            <a:br>
+              <a:rPr lang="en-US" dirty="0"/>
+            </a:br>
+            <a:r>
+              <a:rPr lang="en-US" dirty="0"/>
+              <a:t>When there are 5 min left we will wrap up and answer </a:t>
+            </a:r>
+            <a:r>
+              <a:rPr lang="en-US"/>
+              <a:t>together these </a:t>
+            </a:r>
+            <a:r>
+              <a:rPr lang="en-US" dirty="0"/>
+              <a:t>questions.</a:t>
             </a:r>
           </a:p>
         </p:txBody>
@@ -2708,7 +3652,7 @@
           <a:p>
             <a:fld id="{F7021451-1387-4CA6-816F-3879F97B5CBC}" type="slidenum">
               <a:rPr lang="en-US"/>
-              <a:t>28</a:t>
+              <a:t>27</a:t>
             </a:fld>
             <a:endParaRPr lang="en-US"/>
           </a:p>
@@ -2795,7 +3739,7 @@
           <a:p>
             <a:fld id="{F7021451-1387-4CA6-816F-3879F97B5CBC}" type="slidenum">
               <a:rPr lang="en-US"/>
-              <a:t>29</a:t>
+              <a:t>28</a:t>
             </a:fld>
             <a:endParaRPr lang="en-US"/>
           </a:p>
@@ -2858,7 +3802,20 @@
           <a:bodyPr/>
           <a:lstStyle/>
           <a:p>
-            <a:endParaRPr lang="en-US" dirty="0"/>
+            <a:r>
+              <a:rPr lang="en-US" dirty="0"/>
+              <a:t>About the study, we have a cohort that has data from two instruments, so we have proteomics and metabolomics data</a:t>
+            </a:r>
+            <a:br>
+              <a:rPr lang="en-US" dirty="0"/>
+            </a:br>
+            <a:br>
+              <a:rPr lang="en-US" dirty="0"/>
+            </a:br>
+            <a:r>
+              <a:rPr lang="en-US" dirty="0"/>
+              <a:t>See the reference here if you want to scheme through the paper or read after the course.</a:t>
+            </a:r>
           </a:p>
         </p:txBody>
       </p:sp>
@@ -2944,7 +3901,59 @@
           <a:p>
             <a:r>
               <a:rPr lang="en-US" dirty="0"/>
-              <a:t>There is a clinical problem. Sepsis is a dysregulated host response; K. pneumoniae is a common Gram-negative cause; resistant strains roughly double mortality.</a:t>
+              <a:t>There is a clinical problem in this paper was whether </a:t>
+            </a:r>
+            <a:r>
+              <a:rPr lang="en-US" sz="1200" b="1" dirty="0">
+                <a:solidFill>
+                  <a:schemeClr val="tx1"/>
+                </a:solidFill>
+                <a:latin typeface="Cambria" pitchFamily="34" charset="0"/>
+                <a:ea typeface="Cambria" pitchFamily="34" charset="-122"/>
+                <a:cs typeface="Cambria" pitchFamily="34" charset="-120"/>
+              </a:rPr>
+              <a:t>serum profiles tell a resistant from a susceptible Klebsiella pneumoniae infection on day 0 (time of sepsis diagnosis)?</a:t>
+            </a:r>
+          </a:p>
+          <a:p>
+            <a:endParaRPr lang="en-US" sz="1200" b="1" dirty="0">
+              <a:solidFill>
+                <a:schemeClr val="tx1"/>
+              </a:solidFill>
+              <a:latin typeface="Cambria" pitchFamily="34" charset="0"/>
+            </a:endParaRPr>
+          </a:p>
+          <a:p>
+            <a:r>
+              <a:rPr lang="en-US" dirty="0"/>
+              <a:t>Sepsis is a dysregulated host response; K. pneumoniae is a common cause of sepsis; </a:t>
+            </a:r>
+          </a:p>
+          <a:p>
+            <a:endParaRPr lang="en-US" dirty="0"/>
+          </a:p>
+          <a:p>
+            <a:r>
+              <a:rPr lang="en-US" dirty="0"/>
+              <a:t>resistant strains of this bacteria roughly double mortality.</a:t>
+            </a:r>
+          </a:p>
+          <a:p>
+            <a:endParaRPr lang="en-US" dirty="0"/>
+          </a:p>
+          <a:p>
+            <a:r>
+              <a:rPr lang="en-US" dirty="0"/>
+              <a:t>Blood culture and susceptibility testing take about 1-3 days and sometimes treatment can wait that long </a:t>
+            </a:r>
+          </a:p>
+          <a:p>
+            <a:endParaRPr lang="en-US" dirty="0"/>
+          </a:p>
+          <a:p>
+            <a:r>
+              <a:rPr lang="en-US" dirty="0"/>
+              <a:t>So it would be great if just wit serum proteins or metabolites we can tell a resistant from a susceptible infection!</a:t>
             </a:r>
           </a:p>
         </p:txBody>
@@ -3031,7 +4040,74 @@
           <a:p>
             <a:r>
               <a:rPr lang="en-US" dirty="0"/>
-              <a:t>Note the naming: the susceptible group is CSKP in the paper but its sample IDs are KP*. That mismatch matters later when joining tables.</a:t>
+              <a:t>This is an study of 45 septic patients divided on three </a:t>
+            </a:r>
+            <a:r>
+              <a:rPr lang="en-US" dirty="0" err="1"/>
+              <a:t>pathogeneicity</a:t>
+            </a:r>
+            <a:r>
+              <a:rPr lang="en-US" dirty="0"/>
+              <a:t> groups of 15 patients each</a:t>
+            </a:r>
+            <a:br>
+              <a:rPr lang="en-US" dirty="0"/>
+            </a:br>
+            <a:br>
+              <a:rPr lang="en-US" dirty="0"/>
+            </a:br>
+            <a:r>
+              <a:rPr lang="en-US" dirty="0"/>
+              <a:t>Culture negative sepsis (on all microbiology tests)</a:t>
+            </a:r>
+          </a:p>
+          <a:p>
+            <a:r>
+              <a:rPr lang="en-US" dirty="0"/>
+              <a:t>Carbapenem-susceptible K. pneumoniae sepsis</a:t>
+            </a:r>
+          </a:p>
+          <a:p>
+            <a:r>
+              <a:rPr lang="en-US" dirty="0"/>
+              <a:t>Carbapenem-resistant K. pneumoniae sepsis</a:t>
+            </a:r>
+            <a:br>
+              <a:rPr lang="en-US" dirty="0"/>
+            </a:br>
+            <a:endParaRPr lang="en-US" dirty="0"/>
+          </a:p>
+          <a:p>
+            <a:r>
+              <a:rPr lang="en-US" dirty="0"/>
+              <a:t>Why this analysis is hard?</a:t>
+            </a:r>
+          </a:p>
+          <a:p>
+            <a:br>
+              <a:rPr lang="en-US" dirty="0"/>
+            </a:br>
+            <a:r>
+              <a:rPr lang="en-US" dirty="0"/>
+              <a:t>Notice that all patients are sick, so the contrasts  here are between susceptible and resistant</a:t>
+            </a:r>
+          </a:p>
+          <a:p>
+            <a:r>
+              <a:rPr lang="en-US" dirty="0"/>
+              <a:t>Expect that infection severity will dominate the variance, resistance effect should be a small one compared to severity</a:t>
+            </a:r>
+          </a:p>
+          <a:p>
+            <a:r>
+              <a:rPr lang="en-US" dirty="0"/>
+              <a:t>Sample size 15 per group supervised methods will tend to overfit</a:t>
+            </a:r>
+          </a:p>
+          <a:p>
+            <a:r>
+              <a:rPr lang="en-US" dirty="0"/>
+              <a:t> </a:t>
             </a:r>
           </a:p>
         </p:txBody>
@@ -3118,7 +4194,54 @@
           <a:p>
             <a:r>
               <a:rPr lang="en-US" dirty="0"/>
-              <a:t>Two very different technologies: untargeted-ish DIA proteomics with many missing values, and targeted MRM metabolomics with few. Both deposited publicly. The notebooks read small curated tables straight from GitHub.</a:t>
+              <a:t>From the 45 samples we measured proteomics and metabolomics with two different technologies: </a:t>
+            </a:r>
+          </a:p>
+          <a:p>
+            <a:r>
+              <a:rPr lang="en-US" dirty="0"/>
+              <a:t>untargeted-</a:t>
+            </a:r>
+            <a:r>
+              <a:rPr lang="en-US" dirty="0" err="1"/>
+              <a:t>ish</a:t>
+            </a:r>
+            <a:r>
+              <a:rPr lang="en-US" dirty="0"/>
+              <a:t> DIA proteomics with many missing values, </a:t>
+            </a:r>
+          </a:p>
+          <a:p>
+            <a:r>
+              <a:rPr lang="en-US" dirty="0"/>
+              <a:t>and targeted MRM metabolomics with few. </a:t>
+            </a:r>
+          </a:p>
+          <a:p>
+            <a:endParaRPr lang="en-US" dirty="0"/>
+          </a:p>
+          <a:p>
+            <a:r>
+              <a:rPr lang="en-US" dirty="0"/>
+              <a:t>Both datasets were deposited publicly. We tank the authors! </a:t>
+            </a:r>
+          </a:p>
+          <a:p>
+            <a:endParaRPr lang="en-US" dirty="0"/>
+          </a:p>
+          <a:p>
+            <a:r>
+              <a:rPr lang="en-US" dirty="0"/>
+              <a:t>Today you are not going to process the data again, The notebooks read small curated tables straight from GitHub.</a:t>
+            </a:r>
+          </a:p>
+          <a:p>
+            <a:endParaRPr lang="en-US" dirty="0"/>
+          </a:p>
+          <a:p>
+            <a:r>
+              <a:rPr lang="en-US" dirty="0"/>
+              <a:t>The patients have two descriptions of the same physiology which makes integration possible and exciting.</a:t>
             </a:r>
           </a:p>
         </p:txBody>
@@ -3203,7 +4326,19 @@
           <a:bodyPr/>
           <a:lstStyle/>
           <a:p>
+            <a:r>
+              <a:rPr lang="en-US" dirty="0"/>
+              <a:t>Let’s talk briefly about the processing</a:t>
+            </a:r>
+          </a:p>
+          <a:p>
             <a:endParaRPr lang="en-US" dirty="0"/>
+          </a:p>
+          <a:p>
+            <a:r>
+              <a:rPr lang="en-US" dirty="0"/>
+              <a:t>How we go from raw files to feature intensity matrices</a:t>
+            </a:r>
           </a:p>
         </p:txBody>
       </p:sp>
@@ -3289,8 +4424,98 @@
           <a:p>
             <a:r>
               <a:rPr lang="en-US" dirty="0"/>
-              <a:t>Day 2 of the full course ran these pipelines in Colab on test profiles. Today we only show what they do and what they output; the matrices are already in the repository.</a:t>
-            </a:r>
+              <a:t>We tend to use curated pipelines instead of many tools one after another</a:t>
+            </a:r>
+            <a:br>
+              <a:rPr lang="en-US" dirty="0"/>
+            </a:br>
+            <a:br>
+              <a:rPr lang="en-US" dirty="0"/>
+            </a:br>
+            <a:r>
+              <a:rPr lang="en-US" dirty="0"/>
+              <a:t>At BRIGHT we are setting a collection of </a:t>
+            </a:r>
+            <a:r>
+              <a:rPr lang="en-US" dirty="0" err="1"/>
+              <a:t>Nextflow</a:t>
+            </a:r>
+            <a:r>
+              <a:rPr lang="en-US" dirty="0"/>
+              <a:t> pipelines as default to work with different omics.</a:t>
+            </a:r>
+            <a:br>
+              <a:rPr lang="en-US" dirty="0"/>
+            </a:br>
+            <a:br>
+              <a:rPr lang="en-US" dirty="0"/>
+            </a:br>
+            <a:r>
+              <a:rPr lang="en-US" dirty="0"/>
+              <a:t>It is recommendable as we have pinned versions with a clear map of what versions were used of each tool in each pipeline version</a:t>
+            </a:r>
+          </a:p>
+          <a:p>
+            <a:r>
+              <a:rPr lang="en-US" dirty="0"/>
+              <a:t>We ensure reproducibility by using containers (Docker/</a:t>
+            </a:r>
+            <a:r>
+              <a:rPr lang="en-US" dirty="0" err="1"/>
+              <a:t>apptainer</a:t>
+            </a:r>
+            <a:r>
+              <a:rPr lang="en-US" dirty="0"/>
+              <a:t>) shipped together with the software</a:t>
+            </a:r>
+          </a:p>
+          <a:p>
+            <a:r>
+              <a:rPr lang="en-US" dirty="0" err="1"/>
+              <a:t>Nextflow</a:t>
+            </a:r>
+            <a:r>
+              <a:rPr lang="en-US" dirty="0"/>
+              <a:t> offers the possibility of resume pipelines from wherever they stopped/fail</a:t>
+            </a:r>
+          </a:p>
+          <a:p>
+            <a:r>
+              <a:rPr lang="en-US" dirty="0"/>
+              <a:t>And we can use standards defined by the </a:t>
+            </a:r>
+            <a:r>
+              <a:rPr lang="en-US" dirty="0" err="1"/>
+              <a:t>Nextflow</a:t>
+            </a:r>
+            <a:r>
+              <a:rPr lang="en-US" dirty="0"/>
+              <a:t> community or other communities , f </a:t>
+            </a:r>
+            <a:r>
+              <a:rPr lang="en-US" dirty="0" err="1"/>
+              <a:t>eg</a:t>
+            </a:r>
+            <a:r>
+              <a:rPr lang="en-US" dirty="0"/>
+              <a:t> proteomics standards use </a:t>
+            </a:r>
+            <a:r>
+              <a:rPr lang="en-US" dirty="0" err="1"/>
+              <a:t>sdrf</a:t>
+            </a:r>
+            <a:r>
+              <a:rPr lang="en-US" dirty="0"/>
+              <a:t> format for </a:t>
+            </a:r>
+            <a:r>
+              <a:rPr lang="en-US" dirty="0" err="1"/>
+              <a:t>samplesheets</a:t>
+            </a:r>
+            <a:endParaRPr lang="en-US" dirty="0"/>
+          </a:p>
+          <a:p>
+            <a:endParaRPr lang="en-US" dirty="0"/>
           </a:p>
         </p:txBody>
       </p:sp>
@@ -3376,7 +4601,39 @@
           <a:p>
             <a:r>
               <a:rPr lang="en-DK" dirty="0"/>
-              <a:t> </a:t>
+              <a:t>Briefly Nextflow is a workflow orchestrator engine and a workflow programming language </a:t>
+            </a:r>
+            <a:br>
+              <a:rPr lang="en-DK" dirty="0"/>
+            </a:br>
+            <a:endParaRPr lang="en-DK" dirty="0"/>
+          </a:p>
+          <a:p>
+            <a:r>
+              <a:rPr lang="en-DK" dirty="0"/>
+              <a:t>It allows us to have reproducible runs</a:t>
+            </a:r>
+          </a:p>
+          <a:p>
+            <a:r>
+              <a:rPr lang="en-DK" dirty="0"/>
+              <a:t>Portable and scalable pipelines between different platforms</a:t>
+            </a:r>
+          </a:p>
+          <a:p>
+            <a:r>
+              <a:rPr lang="en-DK" dirty="0"/>
+              <a:t>And it integrates with existing tools and industry standards</a:t>
+            </a:r>
+            <a:br>
+              <a:rPr lang="en-DK" dirty="0"/>
+            </a:br>
+            <a:br>
+              <a:rPr lang="en-DK" dirty="0"/>
+            </a:br>
+            <a:r>
+              <a:rPr lang="en-DK" dirty="0"/>
+              <a:t>Nf-core initiative is a collection of curated Nextflow pipelines that you can use to process many different data types (about 158 different pipeline nowadays) built in a modular way so that you can reuse the modules to build yours</a:t>
             </a:r>
           </a:p>
         </p:txBody>
@@ -3723,7 +4980,7 @@
           </a:prstGeom>
           <a:extLst>
             <a:ext uri="{C572A759-6A51-4108-AA02-DFA0A04FC94B}">
-              <ma14:wrappingTextBoxFlag xmlns:ma14="http://schemas.microsoft.com/office/mac/drawingml/2011/main" xmlns="" val="0"/>
+              <ma14:wrappingTextBoxFlag xmlns="" xmlns:ma14="http://schemas.microsoft.com/office/mac/drawingml/2011/main" val="0"/>
             </a:ext>
           </a:extLst>
         </p:spPr>
@@ -3892,7 +5149,7 @@
           </a:prstGeom>
           <a:extLst>
             <a:ext uri="{C572A759-6A51-4108-AA02-DFA0A04FC94B}">
-              <ma14:wrappingTextBoxFlag xmlns:ma14="http://schemas.microsoft.com/office/mac/drawingml/2011/main" xmlns="" val="0"/>
+              <ma14:wrappingTextBoxFlag xmlns="" xmlns:ma14="http://schemas.microsoft.com/office/mac/drawingml/2011/main" val="0"/>
             </a:ext>
           </a:extLst>
         </p:spPr>
@@ -5329,7 +6586,7 @@
           </a:prstGeom>
           <a:extLst>
             <a:ext uri="{C572A759-6A51-4108-AA02-DFA0A04FC94B}">
-              <ma14:wrappingTextBoxFlag xmlns:ma14="http://schemas.microsoft.com/office/mac/drawingml/2011/main" xmlns="" val="0"/>
+              <ma14:wrappingTextBoxFlag xmlns="" xmlns:ma14="http://schemas.microsoft.com/office/mac/drawingml/2011/main" val="0"/>
             </a:ext>
           </a:extLst>
         </p:spPr>
@@ -6630,7 +7887,7 @@
           <p:nvPr/>
         </p:nvPicPr>
         <p:blipFill>
-          <a:blip r:embed="rId2"/>
+          <a:blip r:embed="rId3"/>
           <a:stretch>
             <a:fillRect/>
           </a:stretch>
@@ -7960,7 +9217,7 @@
           </a:prstGeom>
           <a:extLst>
             <a:ext uri="{C572A759-6A51-4108-AA02-DFA0A04FC94B}">
-              <ma14:wrappingTextBoxFlag xmlns:ma14="http://schemas.microsoft.com/office/mac/drawingml/2011/main" xmlns="" val="0"/>
+              <ma14:wrappingTextBoxFlag xmlns="" xmlns:ma14="http://schemas.microsoft.com/office/mac/drawingml/2011/main" val="0"/>
             </a:ext>
           </a:extLst>
         </p:spPr>
@@ -8729,7 +9986,7 @@
           </a:prstGeom>
           <a:extLst>
             <a:ext uri="{C572A759-6A51-4108-AA02-DFA0A04FC94B}">
-              <ma14:wrappingTextBoxFlag xmlns:ma14="http://schemas.microsoft.com/office/mac/drawingml/2011/main" xmlns="" val="0"/>
+              <ma14:wrappingTextBoxFlag xmlns="" xmlns:ma14="http://schemas.microsoft.com/office/mac/drawingml/2011/main" val="0"/>
             </a:ext>
           </a:extLst>
         </p:spPr>
@@ -8903,7 +10160,7 @@
           </a:prstGeom>
           <a:extLst>
             <a:ext uri="{C572A759-6A51-4108-AA02-DFA0A04FC94B}">
-              <ma14:wrappingTextBoxFlag xmlns:ma14="http://schemas.microsoft.com/office/mac/drawingml/2011/main" xmlns="" val="0"/>
+              <ma14:wrappingTextBoxFlag xmlns="" xmlns:ma14="http://schemas.microsoft.com/office/mac/drawingml/2011/main" val="0"/>
             </a:ext>
           </a:extLst>
         </p:spPr>
@@ -10141,7 +11398,7 @@
           </a:prstGeom>
           <a:extLst>
             <a:ext uri="{C572A759-6A51-4108-AA02-DFA0A04FC94B}">
-              <ma14:wrappingTextBoxFlag xmlns:ma14="http://schemas.microsoft.com/office/mac/drawingml/2011/main" xmlns="" val="0"/>
+              <ma14:wrappingTextBoxFlag xmlns="" xmlns:ma14="http://schemas.microsoft.com/office/mac/drawingml/2011/main" val="0"/>
             </a:ext>
           </a:extLst>
         </p:spPr>
@@ -10609,7 +11866,7 @@
           </a:prstGeom>
           <a:extLst>
             <a:ext uri="{C572A759-6A51-4108-AA02-DFA0A04FC94B}">
-              <ma14:wrappingTextBoxFlag xmlns:ma14="http://schemas.microsoft.com/office/mac/drawingml/2011/main" xmlns="" val="0"/>
+              <ma14:wrappingTextBoxFlag xmlns="" xmlns:ma14="http://schemas.microsoft.com/office/mac/drawingml/2011/main" val="0"/>
             </a:ext>
           </a:extLst>
         </p:spPr>
@@ -10931,6 +12188,13 @@
               </a:rPr>
               <a:t>QC CV &lt; patient CV</a:t>
             </a:r>
+          </a:p>
+          <a:p>
+            <a:pPr algn="ctr"/>
+            <a:r>
+              <a:rPr lang="en-US" sz="1400" dirty="0"/>
+              <a:t>near 0 is biology, near 1 is measurement noise</a:t>
+            </a:r>
             <a:endParaRPr lang="en-US" sz="1300" dirty="0"/>
           </a:p>
         </p:txBody>
@@ -11885,7 +13149,7 @@
           </a:prstGeom>
           <a:extLst>
             <a:ext uri="{C572A759-6A51-4108-AA02-DFA0A04FC94B}">
-              <ma14:wrappingTextBoxFlag xmlns:ma14="http://schemas.microsoft.com/office/mac/drawingml/2011/main" xmlns="" val="0"/>
+              <ma14:wrappingTextBoxFlag xmlns="" xmlns:ma14="http://schemas.microsoft.com/office/mac/drawingml/2011/main" val="0"/>
             </a:ext>
           </a:extLst>
         </p:spPr>
@@ -12347,7 +13611,7 @@
           </a:prstGeom>
           <a:extLst>
             <a:ext uri="{C572A759-6A51-4108-AA02-DFA0A04FC94B}">
-              <ma14:wrappingTextBoxFlag xmlns:ma14="http://schemas.microsoft.com/office/mac/drawingml/2011/main" xmlns="" val="0"/>
+              <ma14:wrappingTextBoxFlag xmlns="" xmlns:ma14="http://schemas.microsoft.com/office/mac/drawingml/2011/main" val="0"/>
             </a:ext>
           </a:extLst>
         </p:spPr>
@@ -12386,7 +13650,7 @@
         </p:nvSpPr>
         <p:spPr>
           <a:xfrm>
-            <a:off x="6564284" y="4042186"/>
+            <a:off x="6583680" y="3914954"/>
             <a:ext cx="5437991" cy="1754326"/>
           </a:xfrm>
           <a:prstGeom prst="rect">
@@ -12875,8 +14139,8 @@
         </p:nvSpPr>
         <p:spPr>
           <a:xfrm>
-            <a:off x="548640" y="5623560"/>
-            <a:ext cx="11094415" cy="457200"/>
+            <a:off x="2110155" y="5623560"/>
+            <a:ext cx="8335108" cy="457200"/>
           </a:xfrm>
           <a:prstGeom prst="rect">
             <a:avLst/>
@@ -12892,14 +14156,14 @@
               <a:buNone/>
             </a:pPr>
             <a:r>
-              <a:rPr lang="en-US" sz="1400" i="1" dirty="0">
+              <a:rPr lang="en-US" i="1" dirty="0">
                 <a:solidFill>
                   <a:schemeClr val="accent5"/>
                 </a:solidFill>
               </a:rPr>
               <a:t>So the question for integration is not 'do the groups separate?' but 'what structure is shared, and where does mechanism cross layers?'</a:t>
             </a:r>
-            <a:endParaRPr lang="en-US" sz="1400" dirty="0"/>
+            <a:endParaRPr lang="en-US" dirty="0"/>
           </a:p>
         </p:txBody>
       </p:sp>
@@ -12923,7 +14187,7 @@
           </a:prstGeom>
           <a:extLst>
             <a:ext uri="{C572A759-6A51-4108-AA02-DFA0A04FC94B}">
-              <ma14:wrappingTextBoxFlag xmlns:ma14="http://schemas.microsoft.com/office/mac/drawingml/2011/main" xmlns="" val="0"/>
+              <ma14:wrappingTextBoxFlag xmlns="" xmlns:ma14="http://schemas.microsoft.com/office/mac/drawingml/2011/main" val="0"/>
             </a:ext>
           </a:extLst>
         </p:spPr>
@@ -14090,7 +15354,7 @@
           </a:prstGeom>
           <a:extLst>
             <a:ext uri="{C572A759-6A51-4108-AA02-DFA0A04FC94B}">
-              <ma14:wrappingTextBoxFlag xmlns:ma14="http://schemas.microsoft.com/office/mac/drawingml/2011/main" xmlns="" val="0"/>
+              <ma14:wrappingTextBoxFlag xmlns="" xmlns:ma14="http://schemas.microsoft.com/office/mac/drawingml/2011/main" val="0"/>
             </a:ext>
           </a:extLst>
         </p:spPr>
@@ -14357,7 +15621,7 @@
           </a:prstGeom>
           <a:extLst>
             <a:ext uri="{C572A759-6A51-4108-AA02-DFA0A04FC94B}">
-              <ma14:wrappingTextBoxFlag xmlns:ma14="http://schemas.microsoft.com/office/mac/drawingml/2011/main" xmlns="" val="0"/>
+              <ma14:wrappingTextBoxFlag xmlns="" xmlns:ma14="http://schemas.microsoft.com/office/mac/drawingml/2011/main" val="0"/>
             </a:ext>
           </a:extLst>
         </p:spPr>
@@ -15935,7 +17199,7 @@
         </p:nvSpPr>
         <p:spPr>
           <a:xfrm>
-            <a:off x="548640" y="320040"/>
+            <a:off x="548640" y="360381"/>
             <a:ext cx="11094415" cy="777240"/>
           </a:xfrm>
           <a:prstGeom prst="rect">
@@ -15948,9 +17212,6 @@
           <a:bodyPr wrap="square" lIns="0" tIns="0" rIns="0" bIns="0" rtlCol="0" anchor="ctr"/>
           <a:lstStyle/>
           <a:p>
-            <a:pPr marL="0" indent="0" algn="l">
-              <a:buNone/>
-            </a:pPr>
             <a:r>
               <a:rPr lang="en-US" sz="3200" b="1" dirty="0">
                 <a:solidFill>
@@ -15960,7 +17221,21 @@
                 <a:ea typeface="Cambria" pitchFamily="34" charset="-122"/>
                 <a:cs typeface="Cambria" pitchFamily="34" charset="-120"/>
               </a:rPr>
-              <a:t>Step zero: two views of the same patients</a:t>
+              <a:t>Step zero: two physiology views of the same patients</a:t>
+            </a:r>
+            <a:br>
+              <a:rPr lang="en-US" sz="3200" b="1" dirty="0">
+                <a:solidFill>
+                  <a:schemeClr val="tx1"/>
+                </a:solidFill>
+                <a:latin typeface="Cambria" pitchFamily="34" charset="0"/>
+                <a:ea typeface="Cambria" pitchFamily="34" charset="-122"/>
+                <a:cs typeface="Cambria" pitchFamily="34" charset="-120"/>
+              </a:rPr>
+            </a:br>
+            <a:r>
+              <a:rPr lang="en-US" dirty="0"/>
+              <a:t>The same recipe applied symmetrically to both layers</a:t>
             </a:r>
             <a:endParaRPr lang="en-US" sz="3200" dirty="0"/>
           </a:p>
@@ -15974,7 +17249,7 @@
         </p:nvSpPr>
         <p:spPr>
           <a:xfrm>
-            <a:off x="548640" y="1417320"/>
+            <a:off x="548640" y="1914859"/>
             <a:ext cx="548640" cy="548640"/>
           </a:xfrm>
           <a:prstGeom prst="roundRect">
@@ -16003,7 +17278,7 @@
         </p:nvSpPr>
         <p:spPr>
           <a:xfrm>
-            <a:off x="548640" y="1417320"/>
+            <a:off x="548640" y="1914859"/>
             <a:ext cx="548640" cy="548640"/>
           </a:xfrm>
           <a:prstGeom prst="rect">
@@ -16039,7 +17314,7 @@
         </p:nvSpPr>
         <p:spPr>
           <a:xfrm>
-            <a:off x="1280160" y="1417320"/>
+            <a:off x="1280160" y="1914859"/>
             <a:ext cx="1828800" cy="548640"/>
           </a:xfrm>
           <a:prstGeom prst="rect">
@@ -16075,7 +17350,7 @@
         </p:nvSpPr>
         <p:spPr>
           <a:xfrm>
-            <a:off x="3108960" y="1417320"/>
+            <a:off x="3108960" y="1914859"/>
             <a:ext cx="2743200" cy="548640"/>
           </a:xfrm>
           <a:prstGeom prst="rect">
@@ -16111,7 +17386,7 @@
         </p:nvSpPr>
         <p:spPr>
           <a:xfrm>
-            <a:off x="548640" y="2194560"/>
+            <a:off x="548640" y="2692099"/>
             <a:ext cx="548640" cy="548640"/>
           </a:xfrm>
           <a:prstGeom prst="roundRect">
@@ -16140,7 +17415,7 @@
         </p:nvSpPr>
         <p:spPr>
           <a:xfrm>
-            <a:off x="548640" y="2194560"/>
+            <a:off x="548640" y="2692099"/>
             <a:ext cx="548640" cy="548640"/>
           </a:xfrm>
           <a:prstGeom prst="rect">
@@ -16176,7 +17451,7 @@
         </p:nvSpPr>
         <p:spPr>
           <a:xfrm>
-            <a:off x="1280160" y="2194560"/>
+            <a:off x="1280160" y="2692099"/>
             <a:ext cx="1828800" cy="548640"/>
           </a:xfrm>
           <a:prstGeom prst="rect">
@@ -16212,7 +17487,7 @@
         </p:nvSpPr>
         <p:spPr>
           <a:xfrm>
-            <a:off x="3108960" y="2194560"/>
+            <a:off x="3108960" y="2692099"/>
             <a:ext cx="2743200" cy="548640"/>
           </a:xfrm>
           <a:prstGeom prst="rect">
@@ -16248,7 +17523,7 @@
         </p:nvSpPr>
         <p:spPr>
           <a:xfrm>
-            <a:off x="548640" y="2971800"/>
+            <a:off x="548640" y="3469339"/>
             <a:ext cx="548640" cy="548640"/>
           </a:xfrm>
           <a:prstGeom prst="roundRect">
@@ -16277,7 +17552,7 @@
         </p:nvSpPr>
         <p:spPr>
           <a:xfrm>
-            <a:off x="548640" y="2971800"/>
+            <a:off x="548640" y="3469339"/>
             <a:ext cx="548640" cy="548640"/>
           </a:xfrm>
           <a:prstGeom prst="rect">
@@ -16313,7 +17588,7 @@
         </p:nvSpPr>
         <p:spPr>
           <a:xfrm>
-            <a:off x="1280160" y="2971800"/>
+            <a:off x="1280160" y="3469339"/>
             <a:ext cx="1828800" cy="548640"/>
           </a:xfrm>
           <a:prstGeom prst="rect">
@@ -16349,7 +17624,7 @@
         </p:nvSpPr>
         <p:spPr>
           <a:xfrm>
-            <a:off x="3108960" y="2971800"/>
+            <a:off x="3108960" y="3469339"/>
             <a:ext cx="2743200" cy="548640"/>
           </a:xfrm>
           <a:prstGeom prst="rect">
@@ -16393,7 +17668,7 @@
         </p:nvSpPr>
         <p:spPr>
           <a:xfrm>
-            <a:off x="548640" y="3749040"/>
+            <a:off x="548640" y="4246579"/>
             <a:ext cx="548640" cy="548640"/>
           </a:xfrm>
           <a:prstGeom prst="roundRect">
@@ -16422,7 +17697,7 @@
         </p:nvSpPr>
         <p:spPr>
           <a:xfrm>
-            <a:off x="548640" y="3749040"/>
+            <a:off x="548640" y="4246579"/>
             <a:ext cx="548640" cy="548640"/>
           </a:xfrm>
           <a:prstGeom prst="rect">
@@ -16458,7 +17733,7 @@
         </p:nvSpPr>
         <p:spPr>
           <a:xfrm>
-            <a:off x="1280160" y="3749040"/>
+            <a:off x="1280160" y="4246579"/>
             <a:ext cx="1828800" cy="548640"/>
           </a:xfrm>
           <a:prstGeom prst="rect">
@@ -16494,7 +17769,7 @@
         </p:nvSpPr>
         <p:spPr>
           <a:xfrm>
-            <a:off x="3108960" y="3749040"/>
+            <a:off x="3108960" y="4246579"/>
             <a:ext cx="2743200" cy="548640"/>
           </a:xfrm>
           <a:prstGeom prst="rect">
@@ -16530,7 +17805,7 @@
         </p:nvSpPr>
         <p:spPr>
           <a:xfrm>
-            <a:off x="548640" y="4526280"/>
+            <a:off x="548640" y="5023819"/>
             <a:ext cx="548640" cy="548640"/>
           </a:xfrm>
           <a:prstGeom prst="roundRect">
@@ -16559,7 +17834,7 @@
         </p:nvSpPr>
         <p:spPr>
           <a:xfrm>
-            <a:off x="548640" y="4526280"/>
+            <a:off x="548640" y="5023819"/>
             <a:ext cx="548640" cy="548640"/>
           </a:xfrm>
           <a:prstGeom prst="rect">
@@ -16595,7 +17870,7 @@
         </p:nvSpPr>
         <p:spPr>
           <a:xfrm>
-            <a:off x="1280160" y="4526280"/>
+            <a:off x="1280160" y="5023819"/>
             <a:ext cx="1828800" cy="548640"/>
           </a:xfrm>
           <a:prstGeom prst="rect">
@@ -16631,7 +17906,7 @@
         </p:nvSpPr>
         <p:spPr>
           <a:xfrm>
-            <a:off x="3108960" y="4526280"/>
+            <a:off x="3108960" y="5023819"/>
             <a:ext cx="2743200" cy="548640"/>
           </a:xfrm>
           <a:prstGeom prst="rect">
@@ -16667,7 +17942,7 @@
         </p:nvSpPr>
         <p:spPr>
           <a:xfrm>
-            <a:off x="6217920" y="1417320"/>
+            <a:off x="6217920" y="1914859"/>
             <a:ext cx="5425135" cy="1600200"/>
           </a:xfrm>
           <a:prstGeom prst="roundRect">
@@ -16703,7 +17978,7 @@
         </p:nvSpPr>
         <p:spPr>
           <a:xfrm>
-            <a:off x="6446520" y="1600200"/>
+            <a:off x="6446520" y="2097739"/>
             <a:ext cx="5029200" cy="1280160"/>
           </a:xfrm>
           <a:prstGeom prst="rect">
@@ -16793,7 +18068,7 @@
         </p:nvSpPr>
         <p:spPr>
           <a:xfrm>
-            <a:off x="6217920" y="3291840"/>
+            <a:off x="6217920" y="3789379"/>
             <a:ext cx="5425135" cy="1645920"/>
           </a:xfrm>
           <a:prstGeom prst="rect">
@@ -16869,7 +18144,7 @@
           </a:prstGeom>
           <a:extLst>
             <a:ext uri="{C572A759-6A51-4108-AA02-DFA0A04FC94B}">
-              <ma14:wrappingTextBoxFlag xmlns:ma14="http://schemas.microsoft.com/office/mac/drawingml/2011/main" xmlns="" val="0"/>
+              <ma14:wrappingTextBoxFlag xmlns="" xmlns:ma14="http://schemas.microsoft.com/office/mac/drawingml/2011/main" val="0"/>
             </a:ext>
           </a:extLst>
         </p:spPr>
@@ -16931,7 +18206,7 @@
         </p:nvSpPr>
         <p:spPr>
           <a:xfrm>
-            <a:off x="415600" y="593367"/>
+            <a:off x="415600" y="174590"/>
             <a:ext cx="11360800" cy="763600"/>
           </a:xfrm>
           <a:prstGeom prst="rect">
@@ -16946,10 +18221,10 @@
           <a:p>
             <a:pPr algn="l"/>
             <a:r>
-              <a:rPr lang="es" b="1"/>
+              <a:rPr lang="es" b="1" dirty="0"/>
               <a:t>Method: Similarity Network Fusion (SNF)</a:t>
             </a:r>
-            <a:endParaRPr b="1"/>
+            <a:endParaRPr b="1" dirty="0"/>
           </a:p>
         </p:txBody>
       </p:sp>
@@ -16965,8 +18240,8 @@
         </p:nvSpPr>
         <p:spPr>
           <a:xfrm>
-            <a:off x="415599" y="1536633"/>
-            <a:ext cx="10931273" cy="2616000"/>
+            <a:off x="415600" y="1175186"/>
+            <a:ext cx="11242163" cy="2616000"/>
           </a:xfrm>
           <a:prstGeom prst="rect">
             <a:avLst/>
@@ -16982,18 +18257,18 @@
               <a:buNone/>
             </a:pPr>
             <a:r>
-              <a:rPr lang="es" sz="2400" dirty="0"/>
+              <a:rPr lang="es" sz="2000" dirty="0"/>
               <a:t>A </a:t>
             </a:r>
             <a:r>
-              <a:rPr lang="es" sz="2400" b="1" dirty="0"/>
+              <a:rPr lang="es" sz="2000" b="1" dirty="0"/>
               <a:t>network-based method</a:t>
             </a:r>
             <a:r>
-              <a:rPr lang="es" sz="2400" dirty="0"/>
+              <a:rPr lang="es" sz="2000" dirty="0"/>
               <a:t> to find sample subtypes (compares patients, not variables)</a:t>
             </a:r>
-            <a:endParaRPr sz="2400" dirty="0"/>
+            <a:endParaRPr sz="2000" dirty="0"/>
           </a:p>
           <a:p>
             <a:pPr marL="0" indent="0">
@@ -17003,22 +18278,22 @@
               <a:buNone/>
             </a:pPr>
             <a:r>
-              <a:rPr lang="es" sz="2400" b="1" dirty="0"/>
+              <a:rPr lang="es" sz="2000" b="1" dirty="0"/>
               <a:t>Step 1</a:t>
             </a:r>
             <a:r>
-              <a:rPr lang="es" sz="2400" dirty="0"/>
+              <a:rPr lang="es" sz="2000" dirty="0"/>
               <a:t> Builds a </a:t>
             </a:r>
             <a:r>
-              <a:rPr lang="es" sz="2400" b="1" dirty="0"/>
+              <a:rPr lang="es" sz="2000" b="1" dirty="0"/>
               <a:t>patient similarity network</a:t>
             </a:r>
             <a:r>
-              <a:rPr lang="es" sz="2400" dirty="0"/>
-              <a:t> for each omic data type (e.g., a gene expression network, a methylation network).</a:t>
-            </a:r>
-            <a:endParaRPr sz="2400" dirty="0"/>
+              <a:rPr lang="es" sz="2000" dirty="0"/>
+              <a:t> for each omic data type (e.g based on gene expression, DNA methylation, proteome and metabolome intensities, etc… ).</a:t>
+            </a:r>
+            <a:endParaRPr sz="2000" dirty="0"/>
           </a:p>
           <a:p>
             <a:pPr marL="0" indent="0">
@@ -17028,30 +18303,30 @@
               <a:buNone/>
             </a:pPr>
             <a:r>
-              <a:rPr lang="es" sz="2400" b="1" dirty="0"/>
+              <a:rPr lang="es" sz="2000" b="1" dirty="0"/>
               <a:t>Step 2</a:t>
             </a:r>
             <a:r>
-              <a:rPr lang="es" sz="2400" dirty="0"/>
+              <a:rPr lang="es" sz="2000" dirty="0"/>
               <a:t> Iteratively </a:t>
             </a:r>
             <a:r>
-              <a:rPr lang="es" sz="2400" b="1" dirty="0"/>
+              <a:rPr lang="es" sz="2000" b="1" dirty="0"/>
               <a:t>fuses</a:t>
             </a:r>
             <a:r>
-              <a:rPr lang="es" sz="2400" dirty="0"/>
+              <a:rPr lang="es" sz="2000" dirty="0"/>
               <a:t> these networks into a </a:t>
             </a:r>
             <a:r>
-              <a:rPr lang="es" sz="2400" b="1" dirty="0"/>
+              <a:rPr lang="es" sz="2000" b="1" dirty="0"/>
               <a:t>single, comprehensive patient network</a:t>
             </a:r>
             <a:r>
-              <a:rPr lang="es" sz="2400" dirty="0"/>
+              <a:rPr lang="es" sz="2000" dirty="0"/>
               <a:t>.</a:t>
             </a:r>
-            <a:endParaRPr sz="2400" dirty="0"/>
+            <a:endParaRPr sz="2000" dirty="0"/>
           </a:p>
           <a:p>
             <a:pPr marL="0" indent="0">
@@ -17063,7 +18338,7 @@
               </a:spcAft>
               <a:buNone/>
             </a:pPr>
-            <a:endParaRPr sz="2400" dirty="0"/>
+            <a:endParaRPr sz="2000" dirty="0"/>
           </a:p>
         </p:txBody>
       </p:sp>
@@ -17075,7 +18350,7 @@
         </p:nvSpPr>
         <p:spPr>
           <a:xfrm>
-            <a:off x="2759738" y="6078764"/>
+            <a:off x="1019568" y="6113120"/>
             <a:ext cx="6242994" cy="615513"/>
           </a:xfrm>
           <a:prstGeom prst="rect">
@@ -17121,8 +18396,8 @@
         </p:blipFill>
         <p:spPr>
           <a:xfrm>
-            <a:off x="2143684" y="3675533"/>
-            <a:ext cx="6973033" cy="2361667"/>
+            <a:off x="547684" y="3313912"/>
+            <a:ext cx="7153209" cy="2422690"/>
           </a:xfrm>
           <a:prstGeom prst="rect">
             <a:avLst/>
@@ -17133,6 +18408,101 @@
           </a:ln>
         </p:spPr>
       </p:pic>
+      <p:sp>
+        <p:nvSpPr>
+          <p:cNvPr id="3" name="TextBox 2">
+            <a:extLst>
+              <a:ext uri="{FF2B5EF4-FFF2-40B4-BE49-F238E27FC236}">
+                <a16:creationId xmlns:a16="http://schemas.microsoft.com/office/drawing/2014/main" id="{07EF7C12-F690-7EB3-FE61-DF799E0A80E8}"/>
+              </a:ext>
+            </a:extLst>
+          </p:cNvPr>
+          <p:cNvSpPr txBox="1"/>
+          <p:nvPr/>
+        </p:nvSpPr>
+        <p:spPr>
+          <a:xfrm>
+            <a:off x="7838377" y="3264456"/>
+            <a:ext cx="4461200" cy="2759730"/>
+          </a:xfrm>
+          <a:prstGeom prst="rect">
+            <a:avLst/>
+          </a:prstGeom>
+          <a:noFill/>
+        </p:spPr>
+        <p:txBody>
+          <a:bodyPr wrap="square">
+            <a:spAutoFit/>
+          </a:bodyPr>
+          <a:lstStyle/>
+          <a:p>
+            <a:pPr marL="0" indent="0">
+              <a:buNone/>
+            </a:pPr>
+            <a:r>
+              <a:rPr lang="en-GB" sz="2000" dirty="0"/>
+              <a:t>The f</a:t>
+            </a:r>
+            <a:r>
+              <a:rPr lang="en-GB" sz="2000" b="1" dirty="0"/>
+              <a:t>usion process</a:t>
+            </a:r>
+            <a:r>
+              <a:rPr lang="en-GB" sz="2000" dirty="0"/>
+              <a:t> keeps </a:t>
+            </a:r>
+            <a:r>
+              <a:rPr lang="en-GB" sz="2000" b="1" dirty="0"/>
+              <a:t>strong similarities</a:t>
+            </a:r>
+            <a:r>
+              <a:rPr lang="en-GB" sz="2000" dirty="0"/>
+              <a:t> found </a:t>
+            </a:r>
+            <a:r>
+              <a:rPr lang="en-GB" sz="2000" b="1" dirty="0"/>
+              <a:t>in multiple omics layers</a:t>
+            </a:r>
+            <a:r>
+              <a:rPr lang="en-GB" sz="2000" dirty="0"/>
+              <a:t> and filters out weak, "noisy" connections.</a:t>
+            </a:r>
+          </a:p>
+          <a:p>
+            <a:pPr marL="0" indent="0">
+              <a:spcBef>
+                <a:spcPts val="1600"/>
+              </a:spcBef>
+              <a:buNone/>
+            </a:pPr>
+            <a:r>
+              <a:rPr lang="en-GB" sz="2000" dirty="0"/>
+              <a:t>The final </a:t>
+            </a:r>
+            <a:r>
+              <a:rPr lang="en-GB" sz="2000" b="1" dirty="0"/>
+              <a:t>fused network</a:t>
+            </a:r>
+            <a:r>
+              <a:rPr lang="en-GB" sz="2000" dirty="0"/>
+              <a:t> represents a </a:t>
+            </a:r>
+            <a:r>
+              <a:rPr lang="en-GB" sz="2000" b="1" dirty="0"/>
+              <a:t>robust measure of patient similarity</a:t>
+            </a:r>
+            <a:r>
+              <a:rPr lang="en-GB" sz="2000" dirty="0"/>
+              <a:t> which is then used for </a:t>
+            </a:r>
+            <a:r>
+              <a:rPr lang="en-GB" sz="2000" b="1" dirty="0"/>
+              <a:t>clustering and comparison with clinical groups.</a:t>
+            </a:r>
+            <a:endParaRPr lang="en-GB" sz="2000" dirty="0"/>
+          </a:p>
+        </p:txBody>
+      </p:sp>
     </p:spTree>
   </p:cSld>
   <p:clrMapOvr>
@@ -17142,199 +18512,6 @@
 </file>
 
 <file path=ppt/slides/slide25.xml><?xml version="1.0" encoding="utf-8"?>
-<p:sld xmlns:a="http://schemas.openxmlformats.org/drawingml/2006/main" xmlns:r="http://schemas.openxmlformats.org/officeDocument/2006/relationships" xmlns:p="http://schemas.openxmlformats.org/presentationml/2006/main">
-  <p:cSld>
-    <p:spTree>
-      <p:nvGrpSpPr>
-        <p:cNvPr id="1" name="Shape 269"/>
-        <p:cNvGrpSpPr/>
-        <p:nvPr/>
-      </p:nvGrpSpPr>
-      <p:grpSpPr>
-        <a:xfrm>
-          <a:off x="0" y="0"/>
-          <a:ext cx="0" cy="0"/>
-          <a:chOff x="0" y="0"/>
-          <a:chExt cx="0" cy="0"/>
-        </a:xfrm>
-      </p:grpSpPr>
-      <p:sp>
-        <p:nvSpPr>
-          <p:cNvPr id="270" name="Google Shape;270;p31"/>
-          <p:cNvSpPr txBox="1">
-            <a:spLocks noGrp="1"/>
-          </p:cNvSpPr>
-          <p:nvPr>
-            <p:ph type="body" idx="1"/>
-          </p:nvPr>
-        </p:nvSpPr>
-        <p:spPr>
-          <a:xfrm>
-            <a:off x="415600" y="1536633"/>
-            <a:ext cx="11360800" cy="4555200"/>
-          </a:xfrm>
-          <a:prstGeom prst="rect">
-            <a:avLst/>
-          </a:prstGeom>
-        </p:spPr>
-        <p:txBody>
-          <a:bodyPr spcFirstLastPara="1" wrap="square" lIns="121900" tIns="121900" rIns="121900" bIns="121900" anchor="t" anchorCtr="0">
-            <a:normAutofit/>
-          </a:bodyPr>
-          <a:lstStyle/>
-          <a:p>
-            <a:pPr marL="0" indent="0">
-              <a:buNone/>
-            </a:pPr>
-            <a:r>
-              <a:rPr lang="es" sz="2400" dirty="0"/>
-              <a:t>The f</a:t>
-            </a:r>
-            <a:r>
-              <a:rPr lang="es" sz="2400" b="1" dirty="0"/>
-              <a:t>usion process</a:t>
-            </a:r>
-            <a:r>
-              <a:rPr lang="es" sz="2400" dirty="0"/>
-              <a:t> finds </a:t>
-            </a:r>
-            <a:r>
-              <a:rPr lang="es" sz="2400" b="1" dirty="0"/>
-              <a:t>strong similarities</a:t>
-            </a:r>
-            <a:r>
-              <a:rPr lang="es" sz="2400" dirty="0"/>
-              <a:t> found </a:t>
-            </a:r>
-            <a:r>
-              <a:rPr lang="es" sz="2400" b="1" dirty="0"/>
-              <a:t>in multiple omics layers</a:t>
-            </a:r>
-            <a:r>
-              <a:rPr lang="es" sz="2400" dirty="0"/>
-              <a:t> and filters out weak, "noisy" connections.</a:t>
-            </a:r>
-            <a:endParaRPr sz="2400" dirty="0"/>
-          </a:p>
-          <a:p>
-            <a:pPr marL="0" indent="0">
-              <a:spcBef>
-                <a:spcPts val="1600"/>
-              </a:spcBef>
-              <a:buNone/>
-            </a:pPr>
-            <a:r>
-              <a:rPr lang="es" sz="2400" dirty="0"/>
-              <a:t>The final </a:t>
-            </a:r>
-            <a:r>
-              <a:rPr lang="es" sz="2400" b="1" dirty="0"/>
-              <a:t>fused network</a:t>
-            </a:r>
-            <a:r>
-              <a:rPr lang="es" sz="2400" dirty="0"/>
-              <a:t> represents a </a:t>
-            </a:r>
-            <a:r>
-              <a:rPr lang="es" sz="2400" b="1" dirty="0"/>
-              <a:t>robust measure of patient similarity</a:t>
-            </a:r>
-            <a:r>
-              <a:rPr lang="es" sz="2400" dirty="0"/>
-              <a:t> which is then used for </a:t>
-            </a:r>
-            <a:r>
-              <a:rPr lang="es" sz="2400" b="1" dirty="0"/>
-              <a:t>clustering</a:t>
-            </a:r>
-            <a:r>
-              <a:rPr lang="es" sz="2400" dirty="0"/>
-              <a:t>.</a:t>
-            </a:r>
-            <a:endParaRPr sz="2400" dirty="0"/>
-          </a:p>
-          <a:p>
-            <a:pPr marL="0" indent="0">
-              <a:spcBef>
-                <a:spcPts val="1600"/>
-              </a:spcBef>
-              <a:buNone/>
-            </a:pPr>
-            <a:r>
-              <a:rPr lang="es" sz="2400" b="1" dirty="0"/>
-              <a:t>Pro</a:t>
-            </a:r>
-            <a:r>
-              <a:rPr lang="es" sz="2400" dirty="0"/>
-              <a:t> Tolerates noise and data heterogeneity well.</a:t>
-            </a:r>
-            <a:endParaRPr sz="2400" dirty="0"/>
-          </a:p>
-          <a:p>
-            <a:pPr marL="0" indent="0">
-              <a:spcBef>
-                <a:spcPts val="1600"/>
-              </a:spcBef>
-              <a:spcAft>
-                <a:spcPts val="1600"/>
-              </a:spcAft>
-              <a:buNone/>
-            </a:pPr>
-            <a:r>
-              <a:rPr lang="es" sz="2400" b="1" dirty="0"/>
-              <a:t>Con</a:t>
-            </a:r>
-            <a:r>
-              <a:rPr lang="es" sz="2400" dirty="0"/>
-              <a:t> Does not identify the specific features (genes) driving the clusters.</a:t>
-            </a:r>
-            <a:endParaRPr sz="2400" dirty="0"/>
-          </a:p>
-        </p:txBody>
-      </p:sp>
-      <p:sp>
-        <p:nvSpPr>
-          <p:cNvPr id="271" name="Google Shape;271;p31"/>
-          <p:cNvSpPr txBox="1">
-            <a:spLocks noGrp="1"/>
-          </p:cNvSpPr>
-          <p:nvPr>
-            <p:ph type="title"/>
-          </p:nvPr>
-        </p:nvSpPr>
-        <p:spPr>
-          <a:xfrm>
-            <a:off x="415600" y="593367"/>
-            <a:ext cx="11360800" cy="763600"/>
-          </a:xfrm>
-          <a:prstGeom prst="rect">
-            <a:avLst/>
-          </a:prstGeom>
-        </p:spPr>
-        <p:txBody>
-          <a:bodyPr spcFirstLastPara="1" wrap="square" lIns="121900" tIns="121900" rIns="121900" bIns="121900" anchor="t" anchorCtr="0">
-            <a:normAutofit fontScale="90000"/>
-          </a:bodyPr>
-          <a:lstStyle/>
-          <a:p>
-            <a:pPr algn="l"/>
-            <a:r>
-              <a:rPr lang="es" b="1"/>
-              <a:t>Method: Similarity Network Fusion (SNF)</a:t>
-            </a:r>
-            <a:endParaRPr b="1"/>
-          </a:p>
-        </p:txBody>
-      </p:sp>
-    </p:spTree>
-  </p:cSld>
-  <p:clrMapOvr>
-    <a:masterClrMapping/>
-  </p:clrMapOvr>
-</p:sld>
-</file>
-
-<file path=ppt/slides/slide26.xml><?xml version="1.0" encoding="utf-8"?>
 <p:sld xmlns:a="http://schemas.openxmlformats.org/drawingml/2006/main" xmlns:r="http://schemas.openxmlformats.org/officeDocument/2006/relationships" xmlns:p="http://schemas.openxmlformats.org/presentationml/2006/main">
   <p:cSld>
     <p:spTree>
@@ -17494,7 +18671,7 @@
         <p:spPr>
           <a:xfrm>
             <a:off x="579264" y="1188052"/>
-            <a:ext cx="6888336" cy="5324535"/>
+            <a:ext cx="7017290" cy="5632311"/>
           </a:xfrm>
           <a:prstGeom prst="rect">
             <a:avLst/>
@@ -17537,14 +18714,14 @@
               <a:buChar char="•"/>
             </a:pPr>
             <a:r>
-              <a:rPr lang="en-US" sz="2000" i="1" dirty="0">
-                <a:solidFill>
-                  <a:schemeClr val="accent4"/>
-                </a:solidFill>
-              </a:rPr>
-              <a:t>To find the sources of variation</a:t>
-            </a:r>
-            <a:endParaRPr lang="en-GB" sz="2000" dirty="0"/>
+              <a:rPr lang="en-US" sz="2000" dirty="0"/>
+              <a:t>To find the </a:t>
+            </a:r>
+            <a:r>
+              <a:rPr lang="en-US" sz="2000" b="1" dirty="0"/>
+              <a:t>sources of variation</a:t>
+            </a:r>
+            <a:endParaRPr lang="en-GB" sz="2000" b="1" dirty="0"/>
           </a:p>
           <a:p>
             <a:pPr marL="285750" indent="-285750">
@@ -17564,12 +18741,9 @@
             </a:r>
             <a:r>
               <a:rPr lang="en-GB" sz="2000" b="1" dirty="0"/>
-              <a:t>PCA for multi-omics</a:t>
-            </a:r>
-            <a:r>
-              <a:rPr lang="en-GB" sz="2000" dirty="0"/>
-              <a:t>. </a:t>
-            </a:r>
+              <a:t>PCA for multi-omics (dimensionality reduction tool)</a:t>
+            </a:r>
+            <a:endParaRPr lang="en-GB" sz="2000" dirty="0"/>
           </a:p>
           <a:p>
             <a:endParaRPr lang="en-GB" sz="2000" dirty="0"/>
@@ -17700,7 +18874,7 @@
 </p:sld>
 </file>
 
-<file path=ppt/slides/slide27.xml><?xml version="1.0" encoding="utf-8"?>
+<file path=ppt/slides/slide26.xml><?xml version="1.0" encoding="utf-8"?>
 <p:sld xmlns:a="http://schemas.openxmlformats.org/drawingml/2006/main" xmlns:r="http://schemas.openxmlformats.org/officeDocument/2006/relationships" xmlns:p="http://schemas.openxmlformats.org/presentationml/2006/main">
   <p:cSld>
     <p:spTree>
@@ -17746,10 +18920,10 @@
               <a:buSzPts val="990"/>
             </a:pPr>
             <a:r>
-              <a:rPr lang="es" sz="3227" b="1"/>
-              <a:t>Method: Weighted Gene Coexpression Network Analysis</a:t>
-            </a:r>
-            <a:endParaRPr sz="3227" b="1"/>
+              <a:rPr lang="es" sz="3227" b="1" dirty="0"/>
+              <a:t>Network Biology Analysis</a:t>
+            </a:r>
+            <a:endParaRPr sz="3227" b="1" dirty="0"/>
           </a:p>
         </p:txBody>
       </p:sp>
@@ -17783,7 +18957,7 @@
             </a:pPr>
             <a:r>
               <a:rPr lang="es" sz="1800" dirty="0"/>
-              <a:t>WGCNA’s primary goal is to find </a:t>
+              <a:t>In network biology the primary goal is to find </a:t>
             </a:r>
             <a:r>
               <a:rPr lang="es" sz="1800" b="1" dirty="0"/>
@@ -17799,7 +18973,7 @@
             </a:r>
             <a:r>
               <a:rPr lang="es" sz="1800" dirty="0"/>
-              <a:t> (e.g., co-expressed genes).</a:t>
+              <a:t> (e.g., co-expressed genes, correlated proteins and metabolites).</a:t>
             </a:r>
             <a:endParaRPr sz="1800" dirty="0"/>
           </a:p>
@@ -17823,7 +18997,7 @@
                   <a:srgbClr val="1E293B"/>
                 </a:solidFill>
               </a:rPr>
-              <a:t>WGCNA is used to build </a:t>
+              <a:t>We build </a:t>
             </a:r>
             <a:r>
               <a:rPr lang="es" sz="1800" b="1" dirty="0">
@@ -17847,7 +19021,7 @@
                   <a:srgbClr val="1E293B"/>
                 </a:solidFill>
               </a:rPr>
-              <a:t>modules of genes</a:t>
+              <a:t>modules of proteins</a:t>
             </a:r>
             <a:r>
               <a:rPr lang="es" sz="1800" dirty="0">
@@ -17855,7 +19029,7 @@
                   <a:srgbClr val="1E293B"/>
                 </a:solidFill>
               </a:rPr>
-              <a:t> (from transcriptomics) that are highly </a:t>
+              <a:t> (from proteomics) that are highly </a:t>
             </a:r>
             <a:r>
               <a:rPr lang="es" sz="1800" b="1" dirty="0">
@@ -17922,7 +19096,7 @@
                   <a:srgbClr val="1E293B"/>
                 </a:solidFill>
               </a:rPr>
-              <a:t>key genes</a:t>
+              <a:t>key proteins</a:t>
             </a:r>
             <a:r>
               <a:rPr lang="es" sz="1800" dirty="0">
@@ -18026,7 +19200,7 @@
 </p:sld>
 </file>
 
-<file path=ppt/slides/slide28.xml><?xml version="1.0" encoding="utf-8"?>
+<file path=ppt/slides/slide27.xml><?xml version="1.0" encoding="utf-8"?>
 <p:sld xmlns:a="http://schemas.openxmlformats.org/drawingml/2006/main" xmlns:r="http://schemas.openxmlformats.org/officeDocument/2006/relationships" xmlns:p="http://schemas.openxmlformats.org/presentationml/2006/main">
   <p:cSld name="Slide 23">
     <p:spTree>
@@ -18776,7 +19950,7 @@
           </a:prstGeom>
           <a:extLst>
             <a:ext uri="{C572A759-6A51-4108-AA02-DFA0A04FC94B}">
-              <ma14:wrappingTextBoxFlag xmlns:ma14="http://schemas.microsoft.com/office/mac/drawingml/2011/main" xmlns="" val="0"/>
+              <ma14:wrappingTextBoxFlag xmlns="" xmlns:ma14="http://schemas.microsoft.com/office/mac/drawingml/2011/main" val="0"/>
             </a:ext>
           </a:extLst>
         </p:spPr>
@@ -18795,7 +19969,7 @@
             <a:pPr algn="r"/>
             <a:fld id="{F7021451-1387-4CA6-816F-3879F97B5CBC}" type="slidenum">
               <a:rPr lang="en-US" b="0"/>
-              <a:t>28</a:t>
+              <a:t>27</a:t>
             </a:fld>
             <a:endParaRPr lang="en-US"/>
           </a:p>
@@ -18809,7 +19983,7 @@
 </p:sld>
 </file>
 
-<file path=ppt/slides/slide29.xml><?xml version="1.0" encoding="utf-8"?>
+<file path=ppt/slides/slide28.xml><?xml version="1.0" encoding="utf-8"?>
 <p:sld xmlns:a="http://schemas.openxmlformats.org/drawingml/2006/main" xmlns:r="http://schemas.openxmlformats.org/officeDocument/2006/relationships" xmlns:p="http://schemas.openxmlformats.org/presentationml/2006/main">
   <p:cSld name="Slide 24">
     <p:bg>
@@ -18972,6 +20146,218 @@
         </p:txBody>
       </p:sp>
     </p:spTree>
+  </p:cSld>
+  <p:clrMapOvr>
+    <a:masterClrMapping/>
+  </p:clrMapOvr>
+</p:sld>
+</file>
+
+<file path=ppt/slides/slide29.xml><?xml version="1.0" encoding="utf-8"?>
+<p:sld xmlns:a="http://schemas.openxmlformats.org/drawingml/2006/main" xmlns:r="http://schemas.openxmlformats.org/officeDocument/2006/relationships" xmlns:p="http://schemas.openxmlformats.org/presentationml/2006/main">
+  <p:cSld>
+    <p:bg>
+      <p:bgPr>
+        <a:solidFill>
+          <a:schemeClr val="bg1"/>
+        </a:solidFill>
+        <a:effectLst/>
+      </p:bgPr>
+    </p:bg>
+    <p:spTree>
+      <p:nvGrpSpPr>
+        <p:cNvPr id="1" name=""/>
+        <p:cNvGrpSpPr/>
+        <p:nvPr/>
+      </p:nvGrpSpPr>
+      <p:grpSpPr>
+        <a:xfrm>
+          <a:off x="0" y="0"/>
+          <a:ext cx="0" cy="0"/>
+          <a:chOff x="0" y="0"/>
+          <a:chExt cx="0" cy="0"/>
+        </a:xfrm>
+      </p:grpSpPr>
+      <p:sp>
+        <p:nvSpPr>
+          <p:cNvPr id="4" name="Text 0">
+            <a:extLst>
+              <a:ext uri="{FF2B5EF4-FFF2-40B4-BE49-F238E27FC236}">
+                <a16:creationId xmlns:a16="http://schemas.microsoft.com/office/drawing/2014/main" id="{9FD13FD8-48AD-EBE9-1E1A-508CED26BA98}"/>
+              </a:ext>
+            </a:extLst>
+          </p:cNvPr>
+          <p:cNvSpPr>
+            <a:spLocks noGrp="1"/>
+          </p:cNvSpPr>
+          <p:nvPr>
+            <p:ph type="title" idx="100" hasCustomPrompt="1"/>
+          </p:nvPr>
+        </p:nvSpPr>
+        <p:spPr>
+          <a:xfrm>
+            <a:off x="548792" y="0"/>
+            <a:ext cx="11094415" cy="777240"/>
+          </a:xfrm>
+          <a:prstGeom prst="rect">
+            <a:avLst/>
+          </a:prstGeom>
+          <a:noFill/>
+          <a:ln/>
+        </p:spPr>
+        <p:txBody>
+          <a:bodyPr wrap="square" lIns="0" tIns="0" rIns="0" bIns="0" rtlCol="0" anchor="ctr"/>
+          <a:lstStyle/>
+          <a:p>
+            <a:pPr marL="0" indent="0" algn="l">
+              <a:buNone/>
+            </a:pPr>
+            <a:r>
+              <a:rPr lang="en-US" sz="3200" b="1" dirty="0">
+                <a:solidFill>
+                  <a:schemeClr val="tx1"/>
+                </a:solidFill>
+                <a:latin typeface="Cambria" pitchFamily="34" charset="0"/>
+                <a:ea typeface="Cambria" pitchFamily="34" charset="-122"/>
+                <a:cs typeface="Cambria" pitchFamily="34" charset="-120"/>
+              </a:rPr>
+              <a:t>Answers to the questions</a:t>
+            </a:r>
+            <a:endParaRPr lang="en-US" sz="3200" dirty="0"/>
+          </a:p>
+        </p:txBody>
+      </p:sp>
+      <p:sp>
+        <p:nvSpPr>
+          <p:cNvPr id="5" name="TextBox 4">
+            <a:extLst>
+              <a:ext uri="{FF2B5EF4-FFF2-40B4-BE49-F238E27FC236}">
+                <a16:creationId xmlns:a16="http://schemas.microsoft.com/office/drawing/2014/main" id="{BA0496B5-F860-59C3-919B-3C0360C38FC5}"/>
+              </a:ext>
+            </a:extLst>
+          </p:cNvPr>
+          <p:cNvSpPr txBox="1"/>
+          <p:nvPr/>
+        </p:nvSpPr>
+        <p:spPr>
+          <a:xfrm>
+            <a:off x="548792" y="708660"/>
+            <a:ext cx="11302889" cy="5909310"/>
+          </a:xfrm>
+          <a:prstGeom prst="rect">
+            <a:avLst/>
+          </a:prstGeom>
+          <a:noFill/>
+        </p:spPr>
+        <p:txBody>
+          <a:bodyPr wrap="square" rtlCol="0">
+            <a:spAutoFit/>
+          </a:bodyPr>
+          <a:lstStyle/>
+          <a:p>
+            <a:r>
+              <a:rPr lang="en-DK" b="1" dirty="0"/>
+              <a:t>Multi-omics I — Integration</a:t>
+            </a:r>
+            <a:endParaRPr lang="en-DK" dirty="0"/>
+          </a:p>
+          <a:p>
+            <a:pPr lvl="0"/>
+            <a:r>
+              <a:rPr lang="en-DK" dirty="0">
+                <a:solidFill>
+                  <a:srgbClr val="FF0000"/>
+                </a:solidFill>
+              </a:rPr>
+              <a:t>1. Is the Mantel correlation between the two layers positive? Is the signal shared or complementary?</a:t>
+            </a:r>
+          </a:p>
+          <a:p>
+            <a:pPr lvl="0"/>
+            <a:endParaRPr lang="en-DK" dirty="0"/>
+          </a:p>
+          <a:p>
+            <a:pPr lvl="0"/>
+            <a:r>
+              <a:rPr lang="en-DK" i="1" dirty="0"/>
+              <a:t>The correlation is slightly positive (rho=0.058), but almost zero and statistically non-significant (p = 0.491). This indicates that the global structures of the proteome and the metabolome in this cohort do not strongly mirror each other. Therefore, the signal is highly complementary rather than shared; each layer captures unique biological dimensions of the host response.</a:t>
+            </a:r>
+          </a:p>
+          <a:p>
+            <a:pPr lvl="0"/>
+            <a:endParaRPr lang="en-DK" i="1" dirty="0"/>
+          </a:p>
+          <a:p>
+            <a:pPr lvl="0"/>
+            <a:r>
+              <a:rPr lang="en-DK" dirty="0">
+                <a:solidFill>
+                  <a:srgbClr val="FF0000"/>
+                </a:solidFill>
+              </a:rPr>
+              <a:t>2. Do the SNF clusters match the pathogeneicity groups — or the clinical variables?</a:t>
+            </a:r>
+          </a:p>
+          <a:p>
+            <a:pPr lvl="0"/>
+            <a:endParaRPr lang="en-DK" dirty="0"/>
+          </a:p>
+          <a:p>
+            <a:r>
+              <a:rPr lang="en-GB" i="1" dirty="0"/>
+              <a:t>The clusters do not match the pathogen resistance groups (CSKP vs. CRKP). Instead, they match clinical variables representing the severity of the inflammatory host response. </a:t>
+            </a:r>
+            <a:r>
+              <a:rPr lang="en-DK" dirty="0"/>
+              <a:t>Cluster 1 is characterized by a significantly higher systemic inflammatory profile, while cluster 0 and 2 contain mostly culture negative samples / less severe sepsis.</a:t>
+            </a:r>
+          </a:p>
+          <a:p>
+            <a:pPr lvl="0"/>
+            <a:endParaRPr lang="en-DK" dirty="0"/>
+          </a:p>
+          <a:p>
+            <a:pPr lvl="0"/>
+            <a:r>
+              <a:rPr lang="en-DK" dirty="0">
+                <a:solidFill>
+                  <a:srgbClr val="FF0000"/>
+                </a:solidFill>
+              </a:rPr>
+              <a:t>3. Which MOFA factor tracks group, and which tracks CRP, procalcitonin or creatinine?</a:t>
+            </a:r>
+          </a:p>
+          <a:p>
+            <a:pPr lvl="0"/>
+            <a:endParaRPr lang="en-DK" dirty="0"/>
+          </a:p>
+          <a:p>
+            <a:r>
+              <a:rPr lang="en-DK" i="1" dirty="0"/>
+              <a:t>Factor 2 is the most highly associated with clinical groups (Kruskal-Wallis p = 0.000022).</a:t>
+            </a:r>
+          </a:p>
+          <a:p>
+            <a:r>
+              <a:rPr lang="en-DK" i="1" dirty="0"/>
+              <a:t>Factor 1 has the strongest relationship with systemic inflammatory markers, showing a moderate Spearman correlation with Procalcitonin (rho = 0.452) and CRP (rho = 0.260)</a:t>
+            </a:r>
+            <a:br>
+              <a:rPr lang="en-DK" i="1" dirty="0"/>
+            </a:br>
+            <a:r>
+              <a:rPr lang="en-DK" i="1" dirty="0"/>
+              <a:t>Factor 4 has the strongest relationship with renal function exhibiting a moderate correlation with creatinine (rho = 0.483)</a:t>
+            </a:r>
+          </a:p>
+        </p:txBody>
+      </p:sp>
+    </p:spTree>
+    <p:extLst>
+      <p:ext uri="{BB962C8B-B14F-4D97-AF65-F5344CB8AC3E}">
+        <p14:creationId xmlns:p14="http://schemas.microsoft.com/office/powerpoint/2010/main" val="1311280699"/>
+      </p:ext>
+    </p:extLst>
   </p:cSld>
   <p:clrMapOvr>
     <a:masterClrMapping/>
@@ -19130,7 +20516,7 @@
           </a:prstGeom>
           <a:extLst>
             <a:ext uri="{C572A759-6A51-4108-AA02-DFA0A04FC94B}">
-              <ma14:wrappingTextBoxFlag xmlns:ma14="http://schemas.microsoft.com/office/mac/drawingml/2011/main" xmlns="" val="0"/>
+              <ma14:wrappingTextBoxFlag xmlns="" xmlns:ma14="http://schemas.microsoft.com/office/mac/drawingml/2011/main" val="0"/>
             </a:ext>
           </a:extLst>
         </p:spPr>
@@ -19164,218 +20550,6 @@
 </file>
 
 <file path=ppt/slides/slide30.xml><?xml version="1.0" encoding="utf-8"?>
-<p:sld xmlns:a="http://schemas.openxmlformats.org/drawingml/2006/main" xmlns:r="http://schemas.openxmlformats.org/officeDocument/2006/relationships" xmlns:p="http://schemas.openxmlformats.org/presentationml/2006/main">
-  <p:cSld>
-    <p:bg>
-      <p:bgPr>
-        <a:solidFill>
-          <a:schemeClr val="bg1"/>
-        </a:solidFill>
-        <a:effectLst/>
-      </p:bgPr>
-    </p:bg>
-    <p:spTree>
-      <p:nvGrpSpPr>
-        <p:cNvPr id="1" name=""/>
-        <p:cNvGrpSpPr/>
-        <p:nvPr/>
-      </p:nvGrpSpPr>
-      <p:grpSpPr>
-        <a:xfrm>
-          <a:off x="0" y="0"/>
-          <a:ext cx="0" cy="0"/>
-          <a:chOff x="0" y="0"/>
-          <a:chExt cx="0" cy="0"/>
-        </a:xfrm>
-      </p:grpSpPr>
-      <p:sp>
-        <p:nvSpPr>
-          <p:cNvPr id="4" name="Text 0">
-            <a:extLst>
-              <a:ext uri="{FF2B5EF4-FFF2-40B4-BE49-F238E27FC236}">
-                <a16:creationId xmlns:a16="http://schemas.microsoft.com/office/drawing/2014/main" id="{9FD13FD8-48AD-EBE9-1E1A-508CED26BA98}"/>
-              </a:ext>
-            </a:extLst>
-          </p:cNvPr>
-          <p:cNvSpPr>
-            <a:spLocks noGrp="1"/>
-          </p:cNvSpPr>
-          <p:nvPr>
-            <p:ph type="title" idx="100" hasCustomPrompt="1"/>
-          </p:nvPr>
-        </p:nvSpPr>
-        <p:spPr>
-          <a:xfrm>
-            <a:off x="548792" y="0"/>
-            <a:ext cx="11094415" cy="777240"/>
-          </a:xfrm>
-          <a:prstGeom prst="rect">
-            <a:avLst/>
-          </a:prstGeom>
-          <a:noFill/>
-          <a:ln/>
-        </p:spPr>
-        <p:txBody>
-          <a:bodyPr wrap="square" lIns="0" tIns="0" rIns="0" bIns="0" rtlCol="0" anchor="ctr"/>
-          <a:lstStyle/>
-          <a:p>
-            <a:pPr marL="0" indent="0" algn="l">
-              <a:buNone/>
-            </a:pPr>
-            <a:r>
-              <a:rPr lang="en-US" sz="3200" b="1" dirty="0">
-                <a:solidFill>
-                  <a:schemeClr val="tx1"/>
-                </a:solidFill>
-                <a:latin typeface="Cambria" pitchFamily="34" charset="0"/>
-                <a:ea typeface="Cambria" pitchFamily="34" charset="-122"/>
-                <a:cs typeface="Cambria" pitchFamily="34" charset="-120"/>
-              </a:rPr>
-              <a:t>Answers to the questions</a:t>
-            </a:r>
-            <a:endParaRPr lang="en-US" sz="3200" dirty="0"/>
-          </a:p>
-        </p:txBody>
-      </p:sp>
-      <p:sp>
-        <p:nvSpPr>
-          <p:cNvPr id="5" name="TextBox 4">
-            <a:extLst>
-              <a:ext uri="{FF2B5EF4-FFF2-40B4-BE49-F238E27FC236}">
-                <a16:creationId xmlns:a16="http://schemas.microsoft.com/office/drawing/2014/main" id="{BA0496B5-F860-59C3-919B-3C0360C38FC5}"/>
-              </a:ext>
-            </a:extLst>
-          </p:cNvPr>
-          <p:cNvSpPr txBox="1"/>
-          <p:nvPr/>
-        </p:nvSpPr>
-        <p:spPr>
-          <a:xfrm>
-            <a:off x="548792" y="708660"/>
-            <a:ext cx="11302889" cy="5909310"/>
-          </a:xfrm>
-          <a:prstGeom prst="rect">
-            <a:avLst/>
-          </a:prstGeom>
-          <a:noFill/>
-        </p:spPr>
-        <p:txBody>
-          <a:bodyPr wrap="square" rtlCol="0">
-            <a:spAutoFit/>
-          </a:bodyPr>
-          <a:lstStyle/>
-          <a:p>
-            <a:r>
-              <a:rPr lang="en-DK" b="1" dirty="0"/>
-              <a:t>Multi-omics I — Integration</a:t>
-            </a:r>
-            <a:endParaRPr lang="en-DK" dirty="0"/>
-          </a:p>
-          <a:p>
-            <a:pPr lvl="0"/>
-            <a:r>
-              <a:rPr lang="en-DK" dirty="0">
-                <a:solidFill>
-                  <a:srgbClr val="FF0000"/>
-                </a:solidFill>
-              </a:rPr>
-              <a:t>1. Is the Mantel correlation between the two layers positive? Is the signal shared or complementary?</a:t>
-            </a:r>
-          </a:p>
-          <a:p>
-            <a:pPr lvl="0"/>
-            <a:endParaRPr lang="en-DK" dirty="0"/>
-          </a:p>
-          <a:p>
-            <a:pPr lvl="0"/>
-            <a:r>
-              <a:rPr lang="en-DK" i="1" dirty="0"/>
-              <a:t>The correlation is slightly positive (rho=0.058), but almost zero and statistically non-significant (p = 0.491). This indicates that the global structures of the proteome and the metabolome in this cohort do not strongly mirror each other. Therefore, the signal is highly complementary rather than shared; each layer captures unique biological dimensions of the host response.</a:t>
-            </a:r>
-          </a:p>
-          <a:p>
-            <a:pPr lvl="0"/>
-            <a:endParaRPr lang="en-DK" i="1" dirty="0"/>
-          </a:p>
-          <a:p>
-            <a:pPr lvl="0"/>
-            <a:r>
-              <a:rPr lang="en-DK" dirty="0">
-                <a:solidFill>
-                  <a:srgbClr val="FF0000"/>
-                </a:solidFill>
-              </a:rPr>
-              <a:t>2. Do the SNF clusters match the pathogeneicity groups — or the clinical variables?</a:t>
-            </a:r>
-          </a:p>
-          <a:p>
-            <a:pPr lvl="0"/>
-            <a:endParaRPr lang="en-DK" dirty="0"/>
-          </a:p>
-          <a:p>
-            <a:r>
-              <a:rPr lang="en-GB" i="1" dirty="0"/>
-              <a:t>The clusters do not match the pathogen resistance groups (CSKP vs. CRKP). Instead, they match clinical variables representing the severity of the inflammatory host response. </a:t>
-            </a:r>
-            <a:r>
-              <a:rPr lang="en-DK" dirty="0"/>
-              <a:t>Cluster 1 is characterized by a significantly higher systemic inflammatory profile, while cluster 0 and 2 contain mostly culture negative samples / less severe sepsis.</a:t>
-            </a:r>
-          </a:p>
-          <a:p>
-            <a:pPr lvl="0"/>
-            <a:endParaRPr lang="en-DK" dirty="0"/>
-          </a:p>
-          <a:p>
-            <a:pPr lvl="0"/>
-            <a:r>
-              <a:rPr lang="en-DK" dirty="0">
-                <a:solidFill>
-                  <a:srgbClr val="FF0000"/>
-                </a:solidFill>
-              </a:rPr>
-              <a:t>3. Which MOFA factor tracks group, and which tracks CRP, procalcitonin or creatinine?</a:t>
-            </a:r>
-          </a:p>
-          <a:p>
-            <a:pPr lvl="0"/>
-            <a:endParaRPr lang="en-DK" dirty="0"/>
-          </a:p>
-          <a:p>
-            <a:r>
-              <a:rPr lang="en-DK" i="1" dirty="0"/>
-              <a:t>Factor 2 is the most highly associated with clinical groups (Kruskal-Wallis p = 0.000022).</a:t>
-            </a:r>
-          </a:p>
-          <a:p>
-            <a:r>
-              <a:rPr lang="en-DK" i="1" dirty="0"/>
-              <a:t>Factor 1 has the strongest relationship with systemic inflammatory markers, showing a moderate Spearman correlation with Procalcitonin (rho = 0.452) and CRP (rho = 0.260)</a:t>
-            </a:r>
-            <a:br>
-              <a:rPr lang="en-DK" i="1" dirty="0"/>
-            </a:br>
-            <a:r>
-              <a:rPr lang="en-DK" i="1" dirty="0"/>
-              <a:t>Factor 4 has the strongest relationship with renal function exhibiting a moderate correlation with creatinine (rho = 0.483)</a:t>
-            </a:r>
-          </a:p>
-        </p:txBody>
-      </p:sp>
-    </p:spTree>
-    <p:extLst>
-      <p:ext uri="{BB962C8B-B14F-4D97-AF65-F5344CB8AC3E}">
-        <p14:creationId xmlns:p14="http://schemas.microsoft.com/office/powerpoint/2010/main" val="1311280699"/>
-      </p:ext>
-    </p:extLst>
-  </p:cSld>
-  <p:clrMapOvr>
-    <a:masterClrMapping/>
-  </p:clrMapOvr>
-</p:sld>
-</file>
-
-<file path=ppt/slides/slide31.xml><?xml version="1.0" encoding="utf-8"?>
 <p:sld xmlns:a="http://schemas.openxmlformats.org/drawingml/2006/main" xmlns:r="http://schemas.openxmlformats.org/officeDocument/2006/relationships" xmlns:p="http://schemas.openxmlformats.org/presentationml/2006/main">
   <p:cSld>
     <p:bg>
@@ -19598,7 +20772,7 @@
                 <a:ea typeface="Cambria" pitchFamily="34" charset="-122"/>
                 <a:cs typeface="Cambria" pitchFamily="34" charset="-120"/>
               </a:rPr>
-              <a:t>The clinical question: can serum profiles tell a resistant from a susceptible Klebsiella pneumoniae  infection on day 0?</a:t>
+              <a:t>The clinical question: can serum profiles tell a resistant from a susceptible Klebsiella pneumoniae  infection on day 0 (time of sepsis diagnosis)?</a:t>
             </a:r>
             <a:endParaRPr lang="en-US" sz="3200" dirty="0"/>
           </a:p>
@@ -19612,7 +20786,7 @@
         </p:nvSpPr>
         <p:spPr>
           <a:xfrm>
-            <a:off x="548640" y="1600200"/>
+            <a:off x="548945" y="2423160"/>
             <a:ext cx="3474720" cy="3291840"/>
           </a:xfrm>
           <a:prstGeom prst="roundRect">
@@ -19650,7 +20824,7 @@
         </p:nvSpPr>
         <p:spPr>
           <a:xfrm>
-            <a:off x="822960" y="1828800"/>
+            <a:off x="823265" y="2651760"/>
             <a:ext cx="2926080" cy="1005840"/>
           </a:xfrm>
           <a:prstGeom prst="rect">
@@ -19689,7 +20863,7 @@
         </p:nvSpPr>
         <p:spPr>
           <a:xfrm>
-            <a:off x="822960" y="2971800"/>
+            <a:off x="823265" y="3794760"/>
             <a:ext cx="2926080" cy="1737360"/>
           </a:xfrm>
           <a:prstGeom prst="rect">
@@ -19725,7 +20899,7 @@
         </p:nvSpPr>
         <p:spPr>
           <a:xfrm>
-            <a:off x="4297680" y="1600200"/>
+            <a:off x="4297985" y="2423160"/>
             <a:ext cx="3474720" cy="3291840"/>
           </a:xfrm>
           <a:prstGeom prst="roundRect">
@@ -19763,7 +20937,7 @@
         </p:nvSpPr>
         <p:spPr>
           <a:xfrm>
-            <a:off x="4572000" y="1828800"/>
+            <a:off x="4572305" y="2651760"/>
             <a:ext cx="2926080" cy="1005840"/>
           </a:xfrm>
           <a:prstGeom prst="rect">
@@ -19802,7 +20976,7 @@
         </p:nvSpPr>
         <p:spPr>
           <a:xfrm>
-            <a:off x="4572000" y="2971800"/>
+            <a:off x="4572305" y="3794760"/>
             <a:ext cx="2926080" cy="1737360"/>
           </a:xfrm>
           <a:prstGeom prst="rect">
@@ -19838,7 +21012,7 @@
         </p:nvSpPr>
         <p:spPr>
           <a:xfrm>
-            <a:off x="8046720" y="1600200"/>
+            <a:off x="8047025" y="2423160"/>
             <a:ext cx="3474720" cy="3291840"/>
           </a:xfrm>
           <a:prstGeom prst="roundRect">
@@ -19876,7 +21050,7 @@
         </p:nvSpPr>
         <p:spPr>
           <a:xfrm>
-            <a:off x="8321040" y="1828800"/>
+            <a:off x="8321345" y="2651760"/>
             <a:ext cx="2926080" cy="1005840"/>
           </a:xfrm>
           <a:prstGeom prst="rect">
@@ -19915,7 +21089,7 @@
         </p:nvSpPr>
         <p:spPr>
           <a:xfrm>
-            <a:off x="8321040" y="2971800"/>
+            <a:off x="8321345" y="3794760"/>
             <a:ext cx="2926080" cy="1737360"/>
           </a:xfrm>
           <a:prstGeom prst="rect">
@@ -19951,7 +21125,7 @@
         </p:nvSpPr>
         <p:spPr>
           <a:xfrm>
-            <a:off x="548640" y="5257800"/>
+            <a:off x="548945" y="6080760"/>
             <a:ext cx="11094415" cy="548640"/>
           </a:xfrm>
           <a:prstGeom prst="rect">
@@ -19999,7 +21173,7 @@
           </a:prstGeom>
           <a:extLst>
             <a:ext uri="{C572A759-6A51-4108-AA02-DFA0A04FC94B}">
-              <ma14:wrappingTextBoxFlag xmlns:ma14="http://schemas.microsoft.com/office/mac/drawingml/2011/main" xmlns="" val="0"/>
+              <ma14:wrappingTextBoxFlag xmlns="" xmlns:ma14="http://schemas.microsoft.com/office/mac/drawingml/2011/main" val="0"/>
             </a:ext>
           </a:extLst>
         </p:spPr>
@@ -20021,6 +21195,41 @@
               <a:t>4</a:t>
             </a:fld>
             <a:endParaRPr lang="en-US"/>
+          </a:p>
+        </p:txBody>
+      </p:sp>
+      <p:sp>
+        <p:nvSpPr>
+          <p:cNvPr id="13" name="TextBox 12">
+            <a:extLst>
+              <a:ext uri="{FF2B5EF4-FFF2-40B4-BE49-F238E27FC236}">
+                <a16:creationId xmlns:a16="http://schemas.microsoft.com/office/drawing/2014/main" id="{6FCF298C-20FB-F960-A2D0-9C5322D5DECF}"/>
+              </a:ext>
+            </a:extLst>
+          </p:cNvPr>
+          <p:cNvSpPr txBox="1"/>
+          <p:nvPr/>
+        </p:nvSpPr>
+        <p:spPr>
+          <a:xfrm>
+            <a:off x="670254" y="1855694"/>
+            <a:ext cx="9011627" cy="369332"/>
+          </a:xfrm>
+          <a:prstGeom prst="rect">
+            <a:avLst/>
+          </a:prstGeom>
+          <a:noFill/>
+        </p:spPr>
+        <p:txBody>
+          <a:bodyPr wrap="square" rtlCol="0">
+            <a:spAutoFit/>
+          </a:bodyPr>
+          <a:lstStyle/>
+          <a:p>
+            <a:r>
+              <a:rPr lang="en-US" dirty="0"/>
+              <a:t>Sepsis is a dysregulated host response; K. pneumoniae is a common cause of sepsis </a:t>
+            </a:r>
           </a:p>
         </p:txBody>
       </p:sp>
@@ -20217,7 +21426,7 @@
         <p:spPr>
           <a:xfrm>
             <a:off x="2926080" y="1600200"/>
-            <a:ext cx="3566160" cy="731520"/>
+            <a:ext cx="2627555" cy="731520"/>
           </a:xfrm>
           <a:prstGeom prst="rect">
             <a:avLst/>
@@ -20238,7 +21447,7 @@
                   <a:schemeClr val="tx1"/>
                 </a:solidFill>
               </a:rPr>
-              <a:t>Culture-negative sepsis</a:t>
+              <a:t>Culture-negative (on all microbiology tests) sepsis</a:t>
             </a:r>
             <a:endParaRPr lang="en-US" sz="1500" dirty="0"/>
           </a:p>
@@ -20813,7 +22022,7 @@
           </a:prstGeom>
           <a:extLst>
             <a:ext uri="{C572A759-6A51-4108-AA02-DFA0A04FC94B}">
-              <ma14:wrappingTextBoxFlag xmlns:ma14="http://schemas.microsoft.com/office/mac/drawingml/2011/main" xmlns="" val="0"/>
+              <ma14:wrappingTextBoxFlag xmlns="" xmlns:ma14="http://schemas.microsoft.com/office/mac/drawingml/2011/main" val="0"/>
             </a:ext>
           </a:extLst>
         </p:spPr>
@@ -20875,7 +22084,7 @@
         </p:nvSpPr>
         <p:spPr>
           <a:xfrm>
-            <a:off x="548640" y="320040"/>
+            <a:off x="548640" y="293146"/>
             <a:ext cx="11094415" cy="777240"/>
           </a:xfrm>
           <a:prstGeom prst="rect">
@@ -20915,13 +22124,13 @@
           <p:nvPr>
             <p:extLst>
               <p:ext uri="{D42A27DB-BD31-4B8C-83A1-F6EECF244321}">
-                <p14:modId xmlns:p14="http://schemas.microsoft.com/office/powerpoint/2010/main" val="1506732054"/>
+                <p14:modId xmlns:p14="http://schemas.microsoft.com/office/powerpoint/2010/main" val="1655344866"/>
               </p:ext>
             </p:extLst>
           </p:nvPr>
         </p:nvGraphicFramePr>
         <p:xfrm>
-          <a:off x="548640" y="1999221"/>
+          <a:off x="548640" y="2053009"/>
           <a:ext cx="7498080" cy="3645408"/>
         </p:xfrm>
         <a:graphic>
@@ -22640,7 +23849,7 @@
         </p:nvSpPr>
         <p:spPr>
           <a:xfrm>
-            <a:off x="8412480" y="1999221"/>
+            <a:off x="8412480" y="2053009"/>
             <a:ext cx="3230575" cy="3511296"/>
           </a:xfrm>
           <a:prstGeom prst="roundRect">
@@ -22669,7 +23878,7 @@
         </p:nvSpPr>
         <p:spPr>
           <a:xfrm>
-            <a:off x="8641080" y="2227821"/>
+            <a:off x="8641080" y="2281609"/>
             <a:ext cx="685800" cy="685800"/>
           </a:xfrm>
           <a:prstGeom prst="ellipse">
@@ -22704,7 +23913,7 @@
         </p:blipFill>
         <p:spPr>
           <a:xfrm>
-            <a:off x="8812530" y="2399271"/>
+            <a:off x="8812530" y="2453059"/>
             <a:ext cx="342900" cy="342900"/>
           </a:xfrm>
           <a:prstGeom prst="rect">
@@ -22720,7 +23929,7 @@
         </p:nvSpPr>
         <p:spPr>
           <a:xfrm>
-            <a:off x="9464040" y="2273541"/>
+            <a:off x="9464040" y="2327329"/>
             <a:ext cx="2103120" cy="640080"/>
           </a:xfrm>
           <a:prstGeom prst="rect">
@@ -22759,7 +23968,7 @@
         </p:nvSpPr>
         <p:spPr>
           <a:xfrm>
-            <a:off x="8641080" y="3096501"/>
+            <a:off x="8641080" y="3150289"/>
             <a:ext cx="2834640" cy="2194560"/>
           </a:xfrm>
           <a:prstGeom prst="rect">
@@ -22795,7 +24004,7 @@
         </p:nvSpPr>
         <p:spPr>
           <a:xfrm>
-            <a:off x="548640" y="5839701"/>
+            <a:off x="548639" y="5955258"/>
             <a:ext cx="11094415" cy="457200"/>
           </a:xfrm>
           <a:prstGeom prst="rect">
@@ -22867,7 +24076,7 @@
           </a:prstGeom>
           <a:extLst>
             <a:ext uri="{C572A759-6A51-4108-AA02-DFA0A04FC94B}">
-              <ma14:wrappingTextBoxFlag xmlns:ma14="http://schemas.microsoft.com/office/mac/drawingml/2011/main" xmlns="" val="0"/>
+              <ma14:wrappingTextBoxFlag xmlns="" xmlns:ma14="http://schemas.microsoft.com/office/mac/drawingml/2011/main" val="0"/>
             </a:ext>
           </a:extLst>
         </p:spPr>
@@ -22907,7 +24116,7 @@
         <p:spPr>
           <a:xfrm>
             <a:off x="548640" y="1010733"/>
-            <a:ext cx="10812087" cy="923330"/>
+            <a:ext cx="11018520" cy="923330"/>
           </a:xfrm>
           <a:prstGeom prst="rect">
             <a:avLst/>
@@ -23089,7 +24298,7 @@
           </a:prstGeom>
           <a:extLst>
             <a:ext uri="{C572A759-6A51-4108-AA02-DFA0A04FC94B}">
-              <ma14:wrappingTextBoxFlag xmlns:ma14="http://schemas.microsoft.com/office/mac/drawingml/2011/main" xmlns="" val="0"/>
+              <ma14:wrappingTextBoxFlag xmlns="" xmlns:ma14="http://schemas.microsoft.com/office/mac/drawingml/2011/main" val="0"/>
             </a:ext>
           </a:extLst>
         </p:spPr>
@@ -23965,7 +25174,7 @@
           </a:prstGeom>
           <a:extLst>
             <a:ext uri="{C572A759-6A51-4108-AA02-DFA0A04FC94B}">
-              <ma14:wrappingTextBoxFlag xmlns:ma14="http://schemas.microsoft.com/office/mac/drawingml/2011/main" xmlns="" val="0"/>
+              <ma14:wrappingTextBoxFlag xmlns="" xmlns:ma14="http://schemas.microsoft.com/office/mac/drawingml/2011/main" val="0"/>
             </a:ext>
           </a:extLst>
         </p:spPr>

</xml_diff>

<commit_message>
Updated Multiomics II, fixed few things in Multiomics I and added the Multiomics II answers in 01_workshop_introduction.pptx
</commit_message>
<xml_diff>
--- a/slides/01_workshop_introduction.pptx
+++ b/slides/01_workshop_introduction.pptx
@@ -4980,7 +4980,7 @@
           </a:prstGeom>
           <a:extLst>
             <a:ext uri="{C572A759-6A51-4108-AA02-DFA0A04FC94B}">
-              <ma14:wrappingTextBoxFlag xmlns="" xmlns:ma14="http://schemas.microsoft.com/office/mac/drawingml/2011/main" val="0"/>
+              <ma14:wrappingTextBoxFlag xmlns:ma14="http://schemas.microsoft.com/office/mac/drawingml/2011/main" xmlns="" val="0"/>
             </a:ext>
           </a:extLst>
         </p:spPr>
@@ -5149,7 +5149,7 @@
           </a:prstGeom>
           <a:extLst>
             <a:ext uri="{C572A759-6A51-4108-AA02-DFA0A04FC94B}">
-              <ma14:wrappingTextBoxFlag xmlns="" xmlns:ma14="http://schemas.microsoft.com/office/mac/drawingml/2011/main" val="0"/>
+              <ma14:wrappingTextBoxFlag xmlns:ma14="http://schemas.microsoft.com/office/mac/drawingml/2011/main" xmlns="" val="0"/>
             </a:ext>
           </a:extLst>
         </p:spPr>
@@ -5309,7 +5309,7 @@
           <a:p>
             <a:fld id="{F6E21658-ACE2-2240-9971-015791891DE6}" type="datetimeFigureOut">
               <a:rPr lang="en-DK" smtClean="0"/>
-              <a:t>24/10/2026</a:t>
+              <a:t>25/10/2026</a:t>
             </a:fld>
             <a:endParaRPr lang="en-DK"/>
           </a:p>
@@ -6586,7 +6586,7 @@
           </a:prstGeom>
           <a:extLst>
             <a:ext uri="{C572A759-6A51-4108-AA02-DFA0A04FC94B}">
-              <ma14:wrappingTextBoxFlag xmlns="" xmlns:ma14="http://schemas.microsoft.com/office/mac/drawingml/2011/main" val="0"/>
+              <ma14:wrappingTextBoxFlag xmlns:ma14="http://schemas.microsoft.com/office/mac/drawingml/2011/main" xmlns="" val="0"/>
             </a:ext>
           </a:extLst>
         </p:spPr>
@@ -9217,7 +9217,7 @@
           </a:prstGeom>
           <a:extLst>
             <a:ext uri="{C572A759-6A51-4108-AA02-DFA0A04FC94B}">
-              <ma14:wrappingTextBoxFlag xmlns="" xmlns:ma14="http://schemas.microsoft.com/office/mac/drawingml/2011/main" val="0"/>
+              <ma14:wrappingTextBoxFlag xmlns:ma14="http://schemas.microsoft.com/office/mac/drawingml/2011/main" xmlns="" val="0"/>
             </a:ext>
           </a:extLst>
         </p:spPr>
@@ -9986,7 +9986,7 @@
           </a:prstGeom>
           <a:extLst>
             <a:ext uri="{C572A759-6A51-4108-AA02-DFA0A04FC94B}">
-              <ma14:wrappingTextBoxFlag xmlns="" xmlns:ma14="http://schemas.microsoft.com/office/mac/drawingml/2011/main" val="0"/>
+              <ma14:wrappingTextBoxFlag xmlns:ma14="http://schemas.microsoft.com/office/mac/drawingml/2011/main" xmlns="" val="0"/>
             </a:ext>
           </a:extLst>
         </p:spPr>
@@ -10160,7 +10160,7 @@
           </a:prstGeom>
           <a:extLst>
             <a:ext uri="{C572A759-6A51-4108-AA02-DFA0A04FC94B}">
-              <ma14:wrappingTextBoxFlag xmlns="" xmlns:ma14="http://schemas.microsoft.com/office/mac/drawingml/2011/main" val="0"/>
+              <ma14:wrappingTextBoxFlag xmlns:ma14="http://schemas.microsoft.com/office/mac/drawingml/2011/main" xmlns="" val="0"/>
             </a:ext>
           </a:extLst>
         </p:spPr>
@@ -11398,7 +11398,7 @@
           </a:prstGeom>
           <a:extLst>
             <a:ext uri="{C572A759-6A51-4108-AA02-DFA0A04FC94B}">
-              <ma14:wrappingTextBoxFlag xmlns="" xmlns:ma14="http://schemas.microsoft.com/office/mac/drawingml/2011/main" val="0"/>
+              <ma14:wrappingTextBoxFlag xmlns:ma14="http://schemas.microsoft.com/office/mac/drawingml/2011/main" xmlns="" val="0"/>
             </a:ext>
           </a:extLst>
         </p:spPr>
@@ -11866,7 +11866,7 @@
           </a:prstGeom>
           <a:extLst>
             <a:ext uri="{C572A759-6A51-4108-AA02-DFA0A04FC94B}">
-              <ma14:wrappingTextBoxFlag xmlns="" xmlns:ma14="http://schemas.microsoft.com/office/mac/drawingml/2011/main" val="0"/>
+              <ma14:wrappingTextBoxFlag xmlns:ma14="http://schemas.microsoft.com/office/mac/drawingml/2011/main" xmlns="" val="0"/>
             </a:ext>
           </a:extLst>
         </p:spPr>
@@ -13149,7 +13149,7 @@
           </a:prstGeom>
           <a:extLst>
             <a:ext uri="{C572A759-6A51-4108-AA02-DFA0A04FC94B}">
-              <ma14:wrappingTextBoxFlag xmlns="" xmlns:ma14="http://schemas.microsoft.com/office/mac/drawingml/2011/main" val="0"/>
+              <ma14:wrappingTextBoxFlag xmlns:ma14="http://schemas.microsoft.com/office/mac/drawingml/2011/main" xmlns="" val="0"/>
             </a:ext>
           </a:extLst>
         </p:spPr>
@@ -13611,7 +13611,7 @@
           </a:prstGeom>
           <a:extLst>
             <a:ext uri="{C572A759-6A51-4108-AA02-DFA0A04FC94B}">
-              <ma14:wrappingTextBoxFlag xmlns="" xmlns:ma14="http://schemas.microsoft.com/office/mac/drawingml/2011/main" val="0"/>
+              <ma14:wrappingTextBoxFlag xmlns:ma14="http://schemas.microsoft.com/office/mac/drawingml/2011/main" xmlns="" val="0"/>
             </a:ext>
           </a:extLst>
         </p:spPr>
@@ -14187,7 +14187,7 @@
           </a:prstGeom>
           <a:extLst>
             <a:ext uri="{C572A759-6A51-4108-AA02-DFA0A04FC94B}">
-              <ma14:wrappingTextBoxFlag xmlns="" xmlns:ma14="http://schemas.microsoft.com/office/mac/drawingml/2011/main" val="0"/>
+              <ma14:wrappingTextBoxFlag xmlns:ma14="http://schemas.microsoft.com/office/mac/drawingml/2011/main" xmlns="" val="0"/>
             </a:ext>
           </a:extLst>
         </p:spPr>
@@ -15354,7 +15354,7 @@
           </a:prstGeom>
           <a:extLst>
             <a:ext uri="{C572A759-6A51-4108-AA02-DFA0A04FC94B}">
-              <ma14:wrappingTextBoxFlag xmlns="" xmlns:ma14="http://schemas.microsoft.com/office/mac/drawingml/2011/main" val="0"/>
+              <ma14:wrappingTextBoxFlag xmlns:ma14="http://schemas.microsoft.com/office/mac/drawingml/2011/main" xmlns="" val="0"/>
             </a:ext>
           </a:extLst>
         </p:spPr>
@@ -15621,7 +15621,7 @@
           </a:prstGeom>
           <a:extLst>
             <a:ext uri="{C572A759-6A51-4108-AA02-DFA0A04FC94B}">
-              <ma14:wrappingTextBoxFlag xmlns="" xmlns:ma14="http://schemas.microsoft.com/office/mac/drawingml/2011/main" val="0"/>
+              <ma14:wrappingTextBoxFlag xmlns:ma14="http://schemas.microsoft.com/office/mac/drawingml/2011/main" xmlns="" val="0"/>
             </a:ext>
           </a:extLst>
         </p:spPr>
@@ -18144,7 +18144,7 @@
           </a:prstGeom>
           <a:extLst>
             <a:ext uri="{C572A759-6A51-4108-AA02-DFA0A04FC94B}">
-              <ma14:wrappingTextBoxFlag xmlns="" xmlns:ma14="http://schemas.microsoft.com/office/mac/drawingml/2011/main" val="0"/>
+              <ma14:wrappingTextBoxFlag xmlns:ma14="http://schemas.microsoft.com/office/mac/drawingml/2011/main" xmlns="" val="0"/>
             </a:ext>
           </a:extLst>
         </p:spPr>
@@ -19950,7 +19950,7 @@
           </a:prstGeom>
           <a:extLst>
             <a:ext uri="{C572A759-6A51-4108-AA02-DFA0A04FC94B}">
-              <ma14:wrappingTextBoxFlag xmlns="" xmlns:ma14="http://schemas.microsoft.com/office/mac/drawingml/2011/main" val="0"/>
+              <ma14:wrappingTextBoxFlag xmlns:ma14="http://schemas.microsoft.com/office/mac/drawingml/2011/main" xmlns="" val="0"/>
             </a:ext>
           </a:extLst>
         </p:spPr>
@@ -20516,7 +20516,7 @@
           </a:prstGeom>
           <a:extLst>
             <a:ext uri="{C572A759-6A51-4108-AA02-DFA0A04FC94B}">
-              <ma14:wrappingTextBoxFlag xmlns="" xmlns:ma14="http://schemas.microsoft.com/office/mac/drawingml/2011/main" val="0"/>
+              <ma14:wrappingTextBoxFlag xmlns:ma14="http://schemas.microsoft.com/office/mac/drawingml/2011/main" xmlns="" val="0"/>
             </a:ext>
           </a:extLst>
         </p:spPr>
@@ -20598,7 +20598,7 @@
         </p:nvSpPr>
         <p:spPr>
           <a:xfrm>
-            <a:off x="548640" y="320040"/>
+            <a:off x="548792" y="0"/>
             <a:ext cx="11094415" cy="777240"/>
           </a:xfrm>
           <a:prstGeom prst="rect">
@@ -20643,8 +20643,8 @@
         </p:nvSpPr>
         <p:spPr>
           <a:xfrm>
-            <a:off x="803564" y="1537855"/>
-            <a:ext cx="10487891" cy="2308324"/>
+            <a:off x="548792" y="671691"/>
+            <a:ext cx="11094415" cy="5909310"/>
           </a:xfrm>
           <a:prstGeom prst="rect">
             <a:avLst/>
@@ -20666,8 +20666,26 @@
           <a:p>
             <a:pPr lvl="0"/>
             <a:r>
-              <a:rPr lang="en-DK" dirty="0"/>
+              <a:rPr lang="en-DK" dirty="0">
+                <a:solidFill>
+                  <a:srgbClr val="FF0000"/>
+                </a:solidFill>
+              </a:rPr>
               <a:t>1. How many protein–metabolite edges survive FDR 5 %, and how many FDR 20 %?</a:t>
+            </a:r>
+          </a:p>
+          <a:p>
+            <a:pPr lvl="0"/>
+            <a:r>
+              <a:rPr lang="en-DK" i="1" dirty="0"/>
+              <a:t>At FDR 5% only 8 edges survive (with a Spearman rho &gt; 0.45.</a:t>
+            </a:r>
+          </a:p>
+          <a:p>
+            <a:pPr lvl="0"/>
+            <a:r>
+              <a:rPr lang="en-DK" i="1" dirty="0"/>
+              <a:t>At FDR 20% 492 edges survive (331 positive, 161 negative). This gives us enough network structure to map out metabolic communities, but with the warning that about 1 in 5 edges (around 98 of them) are expected to be false positives.</a:t>
             </a:r>
           </a:p>
           <a:p>
@@ -20677,31 +20695,89 @@
           <a:p>
             <a:pPr lvl="0"/>
             <a:r>
-              <a:rPr lang="en-DK" dirty="0"/>
+              <a:rPr lang="en-DK" dirty="0">
+                <a:solidFill>
+                  <a:srgbClr val="FF0000"/>
+                </a:solidFill>
+              </a:rPr>
               <a:t>2. Who are the hubs — metabolic controllers, or markers of a global state?</a:t>
             </a:r>
           </a:p>
           <a:p>
-            <a:pPr lvl="0"/>
-            <a:endParaRPr lang="en-DK"/>
-          </a:p>
-          <a:p>
-            <a:pPr lvl="0"/>
-            <a:r>
-              <a:rPr lang="en-DK"/>
-              <a:t>3. </a:t>
-            </a:r>
-            <a:r>
-              <a:rPr lang="en-DK" dirty="0"/>
-              <a:t>Does MAT2B correlate with S-adenosylmethionine (SAM)? Would you believe it?</a:t>
-            </a:r>
+            <a:r>
+              <a:rPr lang="en-GB" i="1" dirty="0"/>
+              <a:t>Mostly markers of a global state. </a:t>
+            </a:r>
+            <a:r>
+              <a:rPr lang="en-DK" i="1" dirty="0"/>
+              <a:t>For example, the top protein hub F7 (Coagulation Factor VII) and immunoglobulins like IGKV2-29 (which has 31 partners) correlate with many metabolites because they all independently track the systemic collapse, vascular damage, and immune exhaustion of severe CRKP sepsis.</a:t>
+            </a:r>
+            <a:endParaRPr lang="en-GB" dirty="0"/>
           </a:p>
           <a:p>
             <a:pPr lvl="0"/>
             <a:endParaRPr lang="en-DK" dirty="0"/>
           </a:p>
           <a:p>
-            <a:endParaRPr lang="en-DK" dirty="0"/>
+            <a:pPr lvl="0"/>
+            <a:r>
+              <a:rPr lang="en-DK" dirty="0">
+                <a:solidFill>
+                  <a:srgbClr val="FF0000"/>
+                </a:solidFill>
+              </a:rPr>
+              <a:t>3. Does MAT2B correlate with S-adenosylmethionine (SAM)? Would you believe it?</a:t>
+            </a:r>
+          </a:p>
+          <a:p>
+            <a:r>
+              <a:rPr lang="en-DK" dirty="0"/>
+              <a:t>Yes, they correlate: rho = 0.38; p = 0.0358</a:t>
+            </a:r>
+          </a:p>
+          <a:p>
+            <a:pPr lvl="0"/>
+            <a:r>
+              <a:rPr lang="en-DK" dirty="0"/>
+              <a:t>I would believe it with strong skepticism. Why?</a:t>
+            </a:r>
+            <a:br>
+              <a:rPr lang="en-DK" dirty="0"/>
+            </a:br>
+            <a:r>
+              <a:rPr lang="en-DK" dirty="0"/>
+              <a:t>	- Very Small Sample Size: MAT2B is only measured in 30 out of 45 patients. </a:t>
+            </a:r>
+          </a:p>
+          <a:p>
+            <a:pPr lvl="0"/>
+            <a:r>
+              <a:rPr lang="en-DK" dirty="0"/>
+              <a:t>	- Leakage vs. Activity: MAT2B is an </a:t>
+            </a:r>
+            <a:r>
+              <a:rPr lang="en-DK" i="1" dirty="0"/>
+              <a:t>intracellular</a:t>
+            </a:r>
+            <a:r>
+              <a:rPr lang="en-DK" dirty="0"/>
+              <a:t> enzyme. Finding it in the </a:t>
+            </a:r>
+            <a:r>
+              <a:rPr lang="en-DK" i="1" dirty="0"/>
+              <a:t>serum</a:t>
+            </a:r>
+            <a:r>
+              <a:rPr lang="en-DK" dirty="0"/>
+              <a:t> likely means cell death and tissue damage rather than active serum enzyme kinetics.</a:t>
+            </a:r>
+          </a:p>
+          <a:p>
+            <a:pPr lvl="0"/>
+            <a:r>
+              <a:rPr lang="en-DK" dirty="0"/>
+              <a:t>	- Circular Reasoning: We specifically zoomed in on the methionine cycle because the paper's pathway analysis (with FDR = 0.57) pointed us there. Finding a correlation here is a coherence check, not independent biological confirmation.</a:t>
+            </a:r>
           </a:p>
         </p:txBody>
       </p:sp>
@@ -21173,7 +21249,7 @@
           </a:prstGeom>
           <a:extLst>
             <a:ext uri="{C572A759-6A51-4108-AA02-DFA0A04FC94B}">
-              <ma14:wrappingTextBoxFlag xmlns="" xmlns:ma14="http://schemas.microsoft.com/office/mac/drawingml/2011/main" val="0"/>
+              <ma14:wrappingTextBoxFlag xmlns:ma14="http://schemas.microsoft.com/office/mac/drawingml/2011/main" xmlns="" val="0"/>
             </a:ext>
           </a:extLst>
         </p:spPr>
@@ -22022,7 +22098,7 @@
           </a:prstGeom>
           <a:extLst>
             <a:ext uri="{C572A759-6A51-4108-AA02-DFA0A04FC94B}">
-              <ma14:wrappingTextBoxFlag xmlns="" xmlns:ma14="http://schemas.microsoft.com/office/mac/drawingml/2011/main" val="0"/>
+              <ma14:wrappingTextBoxFlag xmlns:ma14="http://schemas.microsoft.com/office/mac/drawingml/2011/main" xmlns="" val="0"/>
             </a:ext>
           </a:extLst>
         </p:spPr>
@@ -24076,7 +24152,7 @@
           </a:prstGeom>
           <a:extLst>
             <a:ext uri="{C572A759-6A51-4108-AA02-DFA0A04FC94B}">
-              <ma14:wrappingTextBoxFlag xmlns="" xmlns:ma14="http://schemas.microsoft.com/office/mac/drawingml/2011/main" val="0"/>
+              <ma14:wrappingTextBoxFlag xmlns:ma14="http://schemas.microsoft.com/office/mac/drawingml/2011/main" xmlns="" val="0"/>
             </a:ext>
           </a:extLst>
         </p:spPr>
@@ -24298,7 +24374,7 @@
           </a:prstGeom>
           <a:extLst>
             <a:ext uri="{C572A759-6A51-4108-AA02-DFA0A04FC94B}">
-              <ma14:wrappingTextBoxFlag xmlns="" xmlns:ma14="http://schemas.microsoft.com/office/mac/drawingml/2011/main" val="0"/>
+              <ma14:wrappingTextBoxFlag xmlns:ma14="http://schemas.microsoft.com/office/mac/drawingml/2011/main" xmlns="" val="0"/>
             </a:ext>
           </a:extLst>
         </p:spPr>
@@ -25174,7 +25250,7 @@
           </a:prstGeom>
           <a:extLst>
             <a:ext uri="{C572A759-6A51-4108-AA02-DFA0A04FC94B}">
-              <ma14:wrappingTextBoxFlag xmlns="" xmlns:ma14="http://schemas.microsoft.com/office/mac/drawingml/2011/main" val="0"/>
+              <ma14:wrappingTextBoxFlag xmlns:ma14="http://schemas.microsoft.com/office/mac/drawingml/2011/main" xmlns="" val="0"/>
             </a:ext>
           </a:extLst>
         </p:spPr>

</xml_diff>